<commit_message>
Open day Yandex cloud
</commit_message>
<xml_diff>
--- a/Analytics/00-4 А:Б тесты - практика/Presentation/00-4 A:B test.pptx
+++ b/Analytics/00-4 А:Б тесты - практика/Presentation/00-4 A:B test.pptx
@@ -5,7 +5,7 @@
     <p:sldMasterId id="2147483648" r:id="rId1"/>
   </p:sldMasterIdLst>
   <p:notesMasterIdLst>
-    <p:notesMasterId r:id="rId21"/>
+    <p:notesMasterId r:id="rId30"/>
   </p:notesMasterIdLst>
   <p:sldIdLst>
     <p:sldId id="256" r:id="rId2"/>
@@ -18,15 +18,24 @@
     <p:sldId id="393" r:id="rId9"/>
     <p:sldId id="342" r:id="rId10"/>
     <p:sldId id="505" r:id="rId11"/>
-    <p:sldId id="391" r:id="rId12"/>
-    <p:sldId id="300" r:id="rId13"/>
-    <p:sldId id="484" r:id="rId14"/>
-    <p:sldId id="364" r:id="rId15"/>
-    <p:sldId id="281" r:id="rId16"/>
-    <p:sldId id="377" r:id="rId17"/>
-    <p:sldId id="301" r:id="rId18"/>
-    <p:sldId id="302" r:id="rId19"/>
-    <p:sldId id="335" r:id="rId20"/>
+    <p:sldId id="506" r:id="rId12"/>
+    <p:sldId id="507" r:id="rId13"/>
+    <p:sldId id="508" r:id="rId14"/>
+    <p:sldId id="509" r:id="rId15"/>
+    <p:sldId id="510" r:id="rId16"/>
+    <p:sldId id="513" r:id="rId17"/>
+    <p:sldId id="514" r:id="rId18"/>
+    <p:sldId id="511" r:id="rId19"/>
+    <p:sldId id="512" r:id="rId20"/>
+    <p:sldId id="391" r:id="rId21"/>
+    <p:sldId id="300" r:id="rId22"/>
+    <p:sldId id="484" r:id="rId23"/>
+    <p:sldId id="364" r:id="rId24"/>
+    <p:sldId id="281" r:id="rId25"/>
+    <p:sldId id="377" r:id="rId26"/>
+    <p:sldId id="301" r:id="rId27"/>
+    <p:sldId id="302" r:id="rId28"/>
+    <p:sldId id="335" r:id="rId29"/>
   </p:sldIdLst>
   <p:sldSz cx="9144000" cy="5143500" type="screen16x9"/>
   <p:notesSz cx="9144000" cy="5143500"/>
@@ -226,7 +235,7 @@
           <a:p>
             <a:fld id="{929D4DEE-AA18-4B6A-845C-60AFD9463AA2}" type="datetimeFigureOut">
               <a:rPr lang="ru-RU" smtClean="0"/>
-              <a:t>20.10.2024</a:t>
+              <a:t>02.11.2024</a:t>
             </a:fld>
             <a:endParaRPr lang="ru-RU"/>
           </a:p>
@@ -602,6 +611,346 @@
   <p:cSld>
     <p:spTree>
       <p:nvGrpSpPr>
+        <p:cNvPr id="1" name="Shape 198"/>
+        <p:cNvGrpSpPr/>
+        <p:nvPr/>
+      </p:nvGrpSpPr>
+      <p:grpSpPr>
+        <a:xfrm>
+          <a:off x="0" y="0"/>
+          <a:ext cx="0" cy="0"/>
+          <a:chOff x="0" y="0"/>
+          <a:chExt cx="0" cy="0"/>
+        </a:xfrm>
+      </p:grpSpPr>
+      <p:sp>
+        <p:nvSpPr>
+          <p:cNvPr id="199" name="Google Shape;199;gdf29b9fb24_0_34:notes"/>
+          <p:cNvSpPr>
+            <a:spLocks noGrp="1" noRot="1" noChangeAspect="1"/>
+          </p:cNvSpPr>
+          <p:nvPr>
+            <p:ph type="sldImg" idx="2"/>
+          </p:nvPr>
+        </p:nvSpPr>
+        <p:spPr>
+          <a:xfrm>
+            <a:off x="381000" y="685800"/>
+            <a:ext cx="6096000" cy="3429000"/>
+          </a:xfrm>
+          <a:custGeom>
+            <a:avLst/>
+            <a:gdLst/>
+            <a:ahLst/>
+            <a:cxnLst/>
+            <a:rect l="l" t="t" r="r" b="b"/>
+            <a:pathLst>
+              <a:path w="120000" h="120000" extrusionOk="0">
+                <a:moveTo>
+                  <a:pt x="0" y="0"/>
+                </a:moveTo>
+                <a:lnTo>
+                  <a:pt x="120000" y="0"/>
+                </a:lnTo>
+                <a:lnTo>
+                  <a:pt x="120000" y="120000"/>
+                </a:lnTo>
+                <a:lnTo>
+                  <a:pt x="0" y="120000"/>
+                </a:lnTo>
+                <a:close/>
+              </a:path>
+            </a:pathLst>
+          </a:custGeom>
+        </p:spPr>
+      </p:sp>
+      <p:sp>
+        <p:nvSpPr>
+          <p:cNvPr id="200" name="Google Shape;200;gdf29b9fb24_0_34:notes"/>
+          <p:cNvSpPr txBox="1">
+            <a:spLocks noGrp="1"/>
+          </p:cNvSpPr>
+          <p:nvPr>
+            <p:ph type="body" idx="1"/>
+          </p:nvPr>
+        </p:nvSpPr>
+        <p:spPr>
+          <a:xfrm>
+            <a:off x="685800" y="4343400"/>
+            <a:ext cx="5486400" cy="4114800"/>
+          </a:xfrm>
+          <a:prstGeom prst="rect">
+            <a:avLst/>
+          </a:prstGeom>
+        </p:spPr>
+        <p:txBody>
+          <a:bodyPr spcFirstLastPara="1" wrap="square" lIns="91425" tIns="91425" rIns="91425" bIns="91425" anchor="t" anchorCtr="0">
+            <a:noAutofit/>
+          </a:bodyPr>
+          <a:lstStyle/>
+          <a:p>
+            <a:pPr marL="0" lvl="0" indent="0" algn="l" rtl="0">
+              <a:spcBef>
+                <a:spcPts val="0"/>
+              </a:spcBef>
+              <a:spcAft>
+                <a:spcPts val="0"/>
+              </a:spcAft>
+              <a:buNone/>
+            </a:pPr>
+            <a:endParaRPr/>
+          </a:p>
+        </p:txBody>
+      </p:sp>
+    </p:spTree>
+    <p:extLst>
+      <p:ext uri="{BB962C8B-B14F-4D97-AF65-F5344CB8AC3E}">
+        <p14:creationId xmlns:p14="http://schemas.microsoft.com/office/powerpoint/2010/main" val="1940394664"/>
+      </p:ext>
+    </p:extLst>
+  </p:cSld>
+  <p:clrMapOvr>
+    <a:masterClrMapping/>
+  </p:clrMapOvr>
+</p:notes>
+</file>
+
+<file path=ppt/notesSlides/notesSlide11.xml><?xml version="1.0" encoding="utf-8"?>
+<p:notes xmlns:a="http://schemas.openxmlformats.org/drawingml/2006/main" xmlns:r="http://schemas.openxmlformats.org/officeDocument/2006/relationships" xmlns:p="http://schemas.openxmlformats.org/presentationml/2006/main" showMasterSp="0" showMasterPhAnim="0">
+  <p:cSld>
+    <p:spTree>
+      <p:nvGrpSpPr>
+        <p:cNvPr id="1" name="Shape 403"/>
+        <p:cNvGrpSpPr/>
+        <p:nvPr/>
+      </p:nvGrpSpPr>
+      <p:grpSpPr>
+        <a:xfrm>
+          <a:off x="0" y="0"/>
+          <a:ext cx="0" cy="0"/>
+          <a:chOff x="0" y="0"/>
+          <a:chExt cx="0" cy="0"/>
+        </a:xfrm>
+      </p:grpSpPr>
+      <p:sp>
+        <p:nvSpPr>
+          <p:cNvPr id="404" name="Google Shape;404;gdf6222e6af_0_16:notes"/>
+          <p:cNvSpPr>
+            <a:spLocks noGrp="1" noRot="1" noChangeAspect="1"/>
+          </p:cNvSpPr>
+          <p:nvPr>
+            <p:ph type="sldImg" idx="2"/>
+          </p:nvPr>
+        </p:nvSpPr>
+        <p:spPr>
+          <a:xfrm>
+            <a:off x="381000" y="685800"/>
+            <a:ext cx="6096000" cy="3429000"/>
+          </a:xfrm>
+          <a:custGeom>
+            <a:avLst/>
+            <a:gdLst/>
+            <a:ahLst/>
+            <a:cxnLst/>
+            <a:rect l="l" t="t" r="r" b="b"/>
+            <a:pathLst>
+              <a:path w="120000" h="120000" extrusionOk="0">
+                <a:moveTo>
+                  <a:pt x="0" y="0"/>
+                </a:moveTo>
+                <a:lnTo>
+                  <a:pt x="120000" y="0"/>
+                </a:lnTo>
+                <a:lnTo>
+                  <a:pt x="120000" y="120000"/>
+                </a:lnTo>
+                <a:lnTo>
+                  <a:pt x="0" y="120000"/>
+                </a:lnTo>
+                <a:close/>
+              </a:path>
+            </a:pathLst>
+          </a:custGeom>
+        </p:spPr>
+      </p:sp>
+      <p:sp>
+        <p:nvSpPr>
+          <p:cNvPr id="405" name="Google Shape;405;gdf6222e6af_0_16:notes"/>
+          <p:cNvSpPr txBox="1">
+            <a:spLocks noGrp="1"/>
+          </p:cNvSpPr>
+          <p:nvPr>
+            <p:ph type="body" idx="1"/>
+          </p:nvPr>
+        </p:nvSpPr>
+        <p:spPr>
+          <a:xfrm>
+            <a:off x="685800" y="4343400"/>
+            <a:ext cx="5486400" cy="4114800"/>
+          </a:xfrm>
+          <a:prstGeom prst="rect">
+            <a:avLst/>
+          </a:prstGeom>
+        </p:spPr>
+        <p:txBody>
+          <a:bodyPr spcFirstLastPara="1" wrap="square" lIns="91425" tIns="91425" rIns="91425" bIns="91425" anchor="t" anchorCtr="0">
+            <a:noAutofit/>
+          </a:bodyPr>
+          <a:lstStyle/>
+          <a:p>
+            <a:pPr marL="0" lvl="0" indent="0" algn="l" rtl="0">
+              <a:spcBef>
+                <a:spcPts val="0"/>
+              </a:spcBef>
+              <a:spcAft>
+                <a:spcPts val="0"/>
+              </a:spcAft>
+              <a:buNone/>
+            </a:pPr>
+            <a:endParaRPr/>
+          </a:p>
+        </p:txBody>
+      </p:sp>
+    </p:spTree>
+  </p:cSld>
+  <p:clrMapOvr>
+    <a:masterClrMapping/>
+  </p:clrMapOvr>
+</p:notes>
+</file>
+
+<file path=ppt/notesSlides/notesSlide12.xml><?xml version="1.0" encoding="utf-8"?>
+<p:notes xmlns:a="http://schemas.openxmlformats.org/drawingml/2006/main" xmlns:r="http://schemas.openxmlformats.org/officeDocument/2006/relationships" xmlns:p="http://schemas.openxmlformats.org/presentationml/2006/main" showMasterSp="0" showMasterPhAnim="0">
+  <p:cSld>
+    <p:spTree>
+      <p:nvGrpSpPr>
+        <p:cNvPr id="1" name="Shape 476"/>
+        <p:cNvGrpSpPr/>
+        <p:nvPr/>
+      </p:nvGrpSpPr>
+      <p:grpSpPr>
+        <a:xfrm>
+          <a:off x="0" y="0"/>
+          <a:ext cx="0" cy="0"/>
+          <a:chOff x="0" y="0"/>
+          <a:chExt cx="0" cy="0"/>
+        </a:xfrm>
+      </p:grpSpPr>
+      <p:sp>
+        <p:nvSpPr>
+          <p:cNvPr id="477" name="Google Shape;477;p45:notes"/>
+          <p:cNvSpPr>
+            <a:spLocks noGrp="1" noRot="1" noChangeAspect="1"/>
+          </p:cNvSpPr>
+          <p:nvPr>
+            <p:ph type="sldImg" idx="2"/>
+          </p:nvPr>
+        </p:nvSpPr>
+        <p:spPr>
+          <a:xfrm>
+            <a:off x="381000" y="685800"/>
+            <a:ext cx="6096000" cy="3429000"/>
+          </a:xfrm>
+          <a:custGeom>
+            <a:avLst/>
+            <a:gdLst/>
+            <a:ahLst/>
+            <a:cxnLst/>
+            <a:rect l="l" t="t" r="r" b="b"/>
+            <a:pathLst>
+              <a:path w="120000" h="120000" extrusionOk="0">
+                <a:moveTo>
+                  <a:pt x="0" y="0"/>
+                </a:moveTo>
+                <a:lnTo>
+                  <a:pt x="120000" y="0"/>
+                </a:lnTo>
+                <a:lnTo>
+                  <a:pt x="120000" y="120000"/>
+                </a:lnTo>
+                <a:lnTo>
+                  <a:pt x="0" y="120000"/>
+                </a:lnTo>
+                <a:close/>
+              </a:path>
+            </a:pathLst>
+          </a:custGeom>
+          <a:noFill/>
+          <a:ln w="9525" cap="flat" cmpd="sng">
+            <a:solidFill>
+              <a:srgbClr val="000000"/>
+            </a:solidFill>
+            <a:prstDash val="solid"/>
+            <a:round/>
+            <a:headEnd type="none" w="sm" len="sm"/>
+            <a:tailEnd type="none" w="sm" len="sm"/>
+          </a:ln>
+        </p:spPr>
+      </p:sp>
+      <p:sp>
+        <p:nvSpPr>
+          <p:cNvPr id="478" name="Google Shape;478;p45:notes"/>
+          <p:cNvSpPr txBox="1">
+            <a:spLocks noGrp="1"/>
+          </p:cNvSpPr>
+          <p:nvPr>
+            <p:ph type="body" idx="1"/>
+          </p:nvPr>
+        </p:nvSpPr>
+        <p:spPr>
+          <a:xfrm>
+            <a:off x="685800" y="4343400"/>
+            <a:ext cx="5486400" cy="4114800"/>
+          </a:xfrm>
+          <a:prstGeom prst="rect">
+            <a:avLst/>
+          </a:prstGeom>
+          <a:noFill/>
+          <a:ln>
+            <a:noFill/>
+          </a:ln>
+        </p:spPr>
+        <p:txBody>
+          <a:bodyPr spcFirstLastPara="1" wrap="square" lIns="91425" tIns="91425" rIns="91425" bIns="91425" anchor="t" anchorCtr="0">
+            <a:noAutofit/>
+          </a:bodyPr>
+          <a:lstStyle/>
+          <a:p>
+            <a:pPr marL="0" lvl="0" indent="0" algn="l" rtl="0">
+              <a:lnSpc>
+                <a:spcPct val="100000"/>
+              </a:lnSpc>
+              <a:spcBef>
+                <a:spcPts val="0"/>
+              </a:spcBef>
+              <a:spcAft>
+                <a:spcPts val="0"/>
+              </a:spcAft>
+              <a:buSzPts val="1100"/>
+              <a:buNone/>
+            </a:pPr>
+            <a:endParaRPr/>
+          </a:p>
+        </p:txBody>
+      </p:sp>
+    </p:spTree>
+    <p:extLst>
+      <p:ext uri="{BB962C8B-B14F-4D97-AF65-F5344CB8AC3E}">
+        <p14:creationId xmlns:p14="http://schemas.microsoft.com/office/powerpoint/2010/main" val="1120305369"/>
+      </p:ext>
+    </p:extLst>
+  </p:cSld>
+  <p:clrMapOvr>
+    <a:masterClrMapping/>
+  </p:clrMapOvr>
+</p:notes>
+</file>
+
+<file path=ppt/notesSlides/notesSlide13.xml><?xml version="1.0" encoding="utf-8"?>
+<p:notes xmlns:a="http://schemas.openxmlformats.org/drawingml/2006/main" xmlns:r="http://schemas.openxmlformats.org/officeDocument/2006/relationships" xmlns:p="http://schemas.openxmlformats.org/presentationml/2006/main" showMasterSp="0" showMasterPhAnim="0">
+  <p:cSld>
+    <p:spTree>
+      <p:nvGrpSpPr>
         <p:cNvPr id="1" name="Shape 481"/>
         <p:cNvGrpSpPr/>
         <p:nvPr/>
@@ -719,7 +1068,7 @@
 </p:notes>
 </file>
 
-<file path=ppt/notesSlides/notesSlide11.xml><?xml version="1.0" encoding="utf-8"?>
+<file path=ppt/notesSlides/notesSlide14.xml><?xml version="1.0" encoding="utf-8"?>
 <p:notes xmlns:a="http://schemas.openxmlformats.org/drawingml/2006/main" xmlns:r="http://schemas.openxmlformats.org/officeDocument/2006/relationships" xmlns:p="http://schemas.openxmlformats.org/presentationml/2006/main" showMasterSp="0" showMasterPhAnim="0">
   <p:cSld>
     <p:spTree>
@@ -841,7 +1190,7 @@
 </p:notes>
 </file>
 
-<file path=ppt/notesSlides/notesSlide12.xml><?xml version="1.0" encoding="utf-8"?>
+<file path=ppt/notesSlides/notesSlide15.xml><?xml version="1.0" encoding="utf-8"?>
 <p:notes xmlns:a="http://schemas.openxmlformats.org/drawingml/2006/main" xmlns:r="http://schemas.openxmlformats.org/officeDocument/2006/relationships" xmlns:p="http://schemas.openxmlformats.org/presentationml/2006/main" showMasterSp="0" showMasterPhAnim="0">
   <p:cSld>
     <p:spTree>
@@ -1522,6 +1871,11 @@
         </p:txBody>
       </p:sp>
     </p:spTree>
+    <p:extLst>
+      <p:ext uri="{BB962C8B-B14F-4D97-AF65-F5344CB8AC3E}">
+        <p14:creationId xmlns:p14="http://schemas.microsoft.com/office/powerpoint/2010/main" val="2810051490"/>
+      </p:ext>
+    </p:extLst>
   </p:cSld>
   <p:clrMapOvr>
     <a:masterClrMapping/>
@@ -1534,7 +1888,7 @@
   <p:cSld>
     <p:spTree>
       <p:nvGrpSpPr>
-        <p:cNvPr id="1" name="Shape 198"/>
+        <p:cNvPr id="1" name="Shape 476"/>
         <p:cNvGrpSpPr/>
         <p:nvPr/>
       </p:nvGrpSpPr>
@@ -1548,7 +1902,7 @@
       </p:grpSpPr>
       <p:sp>
         <p:nvSpPr>
-          <p:cNvPr id="199" name="Google Shape;199;gdf29b9fb24_0_34:notes"/>
+          <p:cNvPr id="477" name="Google Shape;477;p45:notes"/>
           <p:cNvSpPr>
             <a:spLocks noGrp="1" noRot="1" noChangeAspect="1"/>
           </p:cNvSpPr>
@@ -1585,11 +1939,21 @@
               </a:path>
             </a:pathLst>
           </a:custGeom>
+          <a:noFill/>
+          <a:ln w="9525" cap="flat" cmpd="sng">
+            <a:solidFill>
+              <a:srgbClr val="000000"/>
+            </a:solidFill>
+            <a:prstDash val="solid"/>
+            <a:round/>
+            <a:headEnd type="none" w="sm" len="sm"/>
+            <a:tailEnd type="none" w="sm" len="sm"/>
+          </a:ln>
         </p:spPr>
       </p:sp>
       <p:sp>
         <p:nvSpPr>
-          <p:cNvPr id="200" name="Google Shape;200;gdf29b9fb24_0_34:notes"/>
+          <p:cNvPr id="478" name="Google Shape;478;p45:notes"/>
           <p:cNvSpPr txBox="1">
             <a:spLocks noGrp="1"/>
           </p:cNvSpPr>
@@ -1605,6 +1969,10 @@
           <a:prstGeom prst="rect">
             <a:avLst/>
           </a:prstGeom>
+          <a:noFill/>
+          <a:ln>
+            <a:noFill/>
+          </a:ln>
         </p:spPr>
         <p:txBody>
           <a:bodyPr spcFirstLastPara="1" wrap="square" lIns="91425" tIns="91425" rIns="91425" bIns="91425" anchor="t" anchorCtr="0">
@@ -1613,12 +1981,16 @@
           <a:lstStyle/>
           <a:p>
             <a:pPr marL="0" lvl="0" indent="0" algn="l" rtl="0">
-              <a:spcBef>
-                <a:spcPts val="0"/>
-              </a:spcBef>
-              <a:spcAft>
-                <a:spcPts val="0"/>
-              </a:spcAft>
+              <a:lnSpc>
+                <a:spcPct val="100000"/>
+              </a:lnSpc>
+              <a:spcBef>
+                <a:spcPts val="0"/>
+              </a:spcBef>
+              <a:spcAft>
+                <a:spcPts val="0"/>
+              </a:spcAft>
+              <a:buSzPts val="1100"/>
               <a:buNone/>
             </a:pPr>
             <a:endParaRPr/>
@@ -1628,7 +2000,7 @@
     </p:spTree>
     <p:extLst>
       <p:ext uri="{BB962C8B-B14F-4D97-AF65-F5344CB8AC3E}">
-        <p14:creationId xmlns:p14="http://schemas.microsoft.com/office/powerpoint/2010/main" val="1940394664"/>
+        <p14:creationId xmlns:p14="http://schemas.microsoft.com/office/powerpoint/2010/main" val="3114862164"/>
       </p:ext>
     </p:extLst>
   </p:cSld>
@@ -1643,7 +2015,7 @@
   <p:cSld>
     <p:spTree>
       <p:nvGrpSpPr>
-        <p:cNvPr id="1" name="Shape 403"/>
+        <p:cNvPr id="1" name="Shape 476"/>
         <p:cNvGrpSpPr/>
         <p:nvPr/>
       </p:nvGrpSpPr>
@@ -1657,7 +2029,7 @@
       </p:grpSpPr>
       <p:sp>
         <p:nvSpPr>
-          <p:cNvPr id="404" name="Google Shape;404;gdf6222e6af_0_16:notes"/>
+          <p:cNvPr id="477" name="Google Shape;477;p45:notes"/>
           <p:cNvSpPr>
             <a:spLocks noGrp="1" noRot="1" noChangeAspect="1"/>
           </p:cNvSpPr>
@@ -1694,11 +2066,21 @@
               </a:path>
             </a:pathLst>
           </a:custGeom>
+          <a:noFill/>
+          <a:ln w="9525" cap="flat" cmpd="sng">
+            <a:solidFill>
+              <a:srgbClr val="000000"/>
+            </a:solidFill>
+            <a:prstDash val="solid"/>
+            <a:round/>
+            <a:headEnd type="none" w="sm" len="sm"/>
+            <a:tailEnd type="none" w="sm" len="sm"/>
+          </a:ln>
         </p:spPr>
       </p:sp>
       <p:sp>
         <p:nvSpPr>
-          <p:cNvPr id="405" name="Google Shape;405;gdf6222e6af_0_16:notes"/>
+          <p:cNvPr id="478" name="Google Shape;478;p45:notes"/>
           <p:cNvSpPr txBox="1">
             <a:spLocks noGrp="1"/>
           </p:cNvSpPr>
@@ -1714,6 +2096,10 @@
           <a:prstGeom prst="rect">
             <a:avLst/>
           </a:prstGeom>
+          <a:noFill/>
+          <a:ln>
+            <a:noFill/>
+          </a:ln>
         </p:spPr>
         <p:txBody>
           <a:bodyPr spcFirstLastPara="1" wrap="square" lIns="91425" tIns="91425" rIns="91425" bIns="91425" anchor="t" anchorCtr="0">
@@ -1722,12 +2108,16 @@
           <a:lstStyle/>
           <a:p>
             <a:pPr marL="0" lvl="0" indent="0" algn="l" rtl="0">
-              <a:spcBef>
-                <a:spcPts val="0"/>
-              </a:spcBef>
-              <a:spcAft>
-                <a:spcPts val="0"/>
-              </a:spcAft>
+              <a:lnSpc>
+                <a:spcPct val="100000"/>
+              </a:lnSpc>
+              <a:spcBef>
+                <a:spcPts val="0"/>
+              </a:spcBef>
+              <a:spcAft>
+                <a:spcPts val="0"/>
+              </a:spcAft>
+              <a:buSzPts val="1100"/>
               <a:buNone/>
             </a:pPr>
             <a:endParaRPr/>
@@ -1735,6 +2125,11 @@
         </p:txBody>
       </p:sp>
     </p:spTree>
+    <p:extLst>
+      <p:ext uri="{BB962C8B-B14F-4D97-AF65-F5344CB8AC3E}">
+        <p14:creationId xmlns:p14="http://schemas.microsoft.com/office/powerpoint/2010/main" val="2000732007"/>
+      </p:ext>
+    </p:extLst>
   </p:cSld>
   <p:clrMapOvr>
     <a:masterClrMapping/>
@@ -1857,11 +2252,6 @@
         </p:txBody>
       </p:sp>
     </p:spTree>
-    <p:extLst>
-      <p:ext uri="{BB962C8B-B14F-4D97-AF65-F5344CB8AC3E}">
-        <p14:creationId xmlns:p14="http://schemas.microsoft.com/office/powerpoint/2010/main" val="1120305369"/>
-      </p:ext>
-    </p:extLst>
   </p:cSld>
   <p:clrMapOvr>
     <a:masterClrMapping/>
@@ -2012,7 +2402,7 @@
           <a:p>
             <a:fld id="{1D8BD707-D9CF-40AE-B4C6-C98DA3205C09}" type="datetimeFigureOut">
               <a:rPr lang="en-US"/>
-              <a:t>10/20/24</a:t>
+              <a:t>11/2/24</a:t>
             </a:fld>
             <a:endParaRPr lang="en-US"/>
           </a:p>
@@ -2187,7 +2577,7 @@
           <a:p>
             <a:fld id="{1D8BD707-D9CF-40AE-B4C6-C98DA3205C09}" type="datetimeFigureOut">
               <a:rPr lang="en-US"/>
-              <a:t>10/20/24</a:t>
+              <a:t>11/2/24</a:t>
             </a:fld>
             <a:endParaRPr lang="en-US"/>
           </a:p>
@@ -2443,7 +2833,7 @@
           <a:p>
             <a:fld id="{1D8BD707-D9CF-40AE-B4C6-C98DA3205C09}" type="datetimeFigureOut">
               <a:rPr lang="en-US"/>
-              <a:t>10/20/24</a:t>
+              <a:t>11/2/24</a:t>
             </a:fld>
             <a:endParaRPr lang="en-US"/>
           </a:p>
@@ -2621,7 +3011,7 @@
           <a:p>
             <a:fld id="{1D8BD707-D9CF-40AE-B4C6-C98DA3205C09}" type="datetimeFigureOut">
               <a:rPr lang="en-US"/>
-              <a:t>10/20/24</a:t>
+              <a:t>11/2/24</a:t>
             </a:fld>
             <a:endParaRPr lang="en-US"/>
           </a:p>
@@ -2740,7 +3130,7 @@
           <a:p>
             <a:fld id="{1D8BD707-D9CF-40AE-B4C6-C98DA3205C09}" type="datetimeFigureOut">
               <a:rPr lang="en-US"/>
-              <a:t>10/20/24</a:t>
+              <a:t>11/2/24</a:t>
             </a:fld>
             <a:endParaRPr lang="en-US"/>
           </a:p>
@@ -5047,7 +5437,7 @@
           <a:p>
             <a:fld id="{1D8BD707-D9CF-40AE-B4C6-C98DA3205C09}" type="datetimeFigureOut">
               <a:rPr lang="en-US"/>
-              <a:t>10/20/24</a:t>
+              <a:t>11/2/24</a:t>
             </a:fld>
             <a:endParaRPr lang="en-US"/>
           </a:p>
@@ -5469,10 +5859,10 @@
       </p:sp>
       <p:pic>
         <p:nvPicPr>
-          <p:cNvPr id="4" name="Picture 3">
+          <p:cNvPr id="6" name="Picture 5">
             <a:extLst>
               <a:ext uri="{FF2B5EF4-FFF2-40B4-BE49-F238E27FC236}">
-                <a16:creationId xmlns:a16="http://schemas.microsoft.com/office/drawing/2014/main" id="{C7D92323-1E4C-D045-B2BE-69AC34C8CB20}"/>
+                <a16:creationId xmlns:a16="http://schemas.microsoft.com/office/drawing/2014/main" id="{46B8A55C-2515-284F-8A3C-403957199EB6}"/>
               </a:ext>
             </a:extLst>
           </p:cNvPr>
@@ -5489,8 +5879,38 @@
         </p:blipFill>
         <p:spPr>
           <a:xfrm>
-            <a:off x="1365250" y="1449220"/>
-            <a:ext cx="6413500" cy="3327400"/>
+            <a:off x="127000" y="1428750"/>
+            <a:ext cx="4445000" cy="3352800"/>
+          </a:xfrm>
+          <a:prstGeom prst="rect">
+            <a:avLst/>
+          </a:prstGeom>
+        </p:spPr>
+      </p:pic>
+      <p:pic>
+        <p:nvPicPr>
+          <p:cNvPr id="7" name="Picture 6">
+            <a:extLst>
+              <a:ext uri="{FF2B5EF4-FFF2-40B4-BE49-F238E27FC236}">
+                <a16:creationId xmlns:a16="http://schemas.microsoft.com/office/drawing/2014/main" id="{EDF52595-D263-294E-B32D-BC6928097B34}"/>
+              </a:ext>
+            </a:extLst>
+          </p:cNvPr>
+          <p:cNvPicPr>
+            <a:picLocks noChangeAspect="1"/>
+          </p:cNvPicPr>
+          <p:nvPr/>
+        </p:nvPicPr>
+        <p:blipFill>
+          <a:blip r:embed="rId3"/>
+          <a:stretch>
+            <a:fillRect/>
+          </a:stretch>
+        </p:blipFill>
+        <p:spPr>
+          <a:xfrm>
+            <a:off x="4699000" y="1454150"/>
+            <a:ext cx="4445000" cy="3327400"/>
           </a:xfrm>
           <a:prstGeom prst="rect">
             <a:avLst/>
@@ -5511,6 +5931,2291 @@
 </file>
 
 <file path=ppt/slides/slide11.xml><?xml version="1.0" encoding="utf-8"?>
+<p:sld xmlns:a="http://schemas.openxmlformats.org/drawingml/2006/main" xmlns:r="http://schemas.openxmlformats.org/officeDocument/2006/relationships" xmlns:p="http://schemas.openxmlformats.org/presentationml/2006/main">
+  <p:cSld>
+    <p:spTree>
+      <p:nvGrpSpPr>
+        <p:cNvPr id="1" name=""/>
+        <p:cNvGrpSpPr/>
+        <p:nvPr/>
+      </p:nvGrpSpPr>
+      <p:grpSpPr>
+        <a:xfrm>
+          <a:off x="0" y="0"/>
+          <a:ext cx="0" cy="0"/>
+          <a:chOff x="0" y="0"/>
+          <a:chExt cx="0" cy="0"/>
+        </a:xfrm>
+      </p:grpSpPr>
+      <p:sp>
+        <p:nvSpPr>
+          <p:cNvPr id="3" name="Title 2">
+            <a:extLst>
+              <a:ext uri="{FF2B5EF4-FFF2-40B4-BE49-F238E27FC236}">
+                <a16:creationId xmlns:a16="http://schemas.microsoft.com/office/drawing/2014/main" id="{B6638231-D78E-9046-971E-9007915E5526}"/>
+              </a:ext>
+            </a:extLst>
+          </p:cNvPr>
+          <p:cNvSpPr>
+            <a:spLocks noGrp="1"/>
+          </p:cNvSpPr>
+          <p:nvPr>
+            <p:ph type="title"/>
+          </p:nvPr>
+        </p:nvSpPr>
+        <p:spPr/>
+        <p:txBody>
+          <a:bodyPr/>
+          <a:lstStyle/>
+          <a:p>
+            <a:r>
+              <a:rPr lang="ru-RU" dirty="0"/>
+              <a:t>Подглядывание</a:t>
+            </a:r>
+            <a:r>
+              <a:rPr lang="en-US" dirty="0"/>
+              <a:t> – </a:t>
+            </a:r>
+            <a:r>
+              <a:rPr lang="ru-RU" dirty="0"/>
+              <a:t>байесовский подход</a:t>
+            </a:r>
+            <a:endParaRPr lang="en-US" dirty="0"/>
+          </a:p>
+        </p:txBody>
+      </p:sp>
+      <p:pic>
+        <p:nvPicPr>
+          <p:cNvPr id="1026" name="Picture 2" descr="Рисунок 2. Апостериорные распределения конверсий в группе А и Б на 1 неделе (линии - стандартные отклонения)">
+            <a:extLst>
+              <a:ext uri="{FF2B5EF4-FFF2-40B4-BE49-F238E27FC236}">
+                <a16:creationId xmlns:a16="http://schemas.microsoft.com/office/drawing/2014/main" id="{BABB5898-27E7-5544-8446-C4E8B80E17B2}"/>
+              </a:ext>
+            </a:extLst>
+          </p:cNvPr>
+          <p:cNvPicPr>
+            <a:picLocks noChangeAspect="1" noChangeArrowheads="1"/>
+          </p:cNvPicPr>
+          <p:nvPr/>
+        </p:nvPicPr>
+        <p:blipFill>
+          <a:blip r:embed="rId2">
+            <a:extLst>
+              <a:ext uri="{28A0092B-C50C-407E-A947-70E740481C1C}">
+                <a14:useLocalDpi xmlns:a14="http://schemas.microsoft.com/office/drawing/2010/main" val="0"/>
+              </a:ext>
+            </a:extLst>
+          </a:blip>
+          <a:srcRect/>
+          <a:stretch>
+            <a:fillRect/>
+          </a:stretch>
+        </p:blipFill>
+        <p:spPr bwMode="auto">
+          <a:xfrm>
+            <a:off x="457200" y="1887150"/>
+            <a:ext cx="3452590" cy="1980000"/>
+          </a:xfrm>
+          <a:prstGeom prst="rect">
+            <a:avLst/>
+          </a:prstGeom>
+          <a:noFill/>
+          <a:extLst>
+            <a:ext uri="{909E8E84-426E-40DD-AFC4-6F175D3DCCD1}">
+              <a14:hiddenFill xmlns:a14="http://schemas.microsoft.com/office/drawing/2010/main">
+                <a:solidFill>
+                  <a:srgbClr val="FFFFFF"/>
+                </a:solidFill>
+              </a14:hiddenFill>
+            </a:ext>
+          </a:extLst>
+        </p:spPr>
+      </p:pic>
+      <p:pic>
+        <p:nvPicPr>
+          <p:cNvPr id="1028" name="Picture 4" descr="Рисунок 4. Апостериорные распределения конверсий в группе А и Б на 4 неделе (линии - стандартные отклонения)">
+            <a:extLst>
+              <a:ext uri="{FF2B5EF4-FFF2-40B4-BE49-F238E27FC236}">
+                <a16:creationId xmlns:a16="http://schemas.microsoft.com/office/drawing/2014/main" id="{260F8E53-7A40-A14B-AD46-E09DA380C6E8}"/>
+              </a:ext>
+            </a:extLst>
+          </p:cNvPr>
+          <p:cNvPicPr>
+            <a:picLocks noChangeAspect="1" noChangeArrowheads="1"/>
+          </p:cNvPicPr>
+          <p:nvPr/>
+        </p:nvPicPr>
+        <p:blipFill>
+          <a:blip r:embed="rId3">
+            <a:extLst>
+              <a:ext uri="{28A0092B-C50C-407E-A947-70E740481C1C}">
+                <a14:useLocalDpi xmlns:a14="http://schemas.microsoft.com/office/drawing/2010/main" val="0"/>
+              </a:ext>
+            </a:extLst>
+          </a:blip>
+          <a:srcRect/>
+          <a:stretch>
+            <a:fillRect/>
+          </a:stretch>
+        </p:blipFill>
+        <p:spPr bwMode="auto">
+          <a:xfrm>
+            <a:off x="5334000" y="1887150"/>
+            <a:ext cx="3456703" cy="1980000"/>
+          </a:xfrm>
+          <a:prstGeom prst="rect">
+            <a:avLst/>
+          </a:prstGeom>
+          <a:noFill/>
+          <a:extLst>
+            <a:ext uri="{909E8E84-426E-40DD-AFC4-6F175D3DCCD1}">
+              <a14:hiddenFill xmlns:a14="http://schemas.microsoft.com/office/drawing/2010/main">
+                <a:solidFill>
+                  <a:srgbClr val="FFFFFF"/>
+                </a:solidFill>
+              </a14:hiddenFill>
+            </a:ext>
+          </a:extLst>
+        </p:spPr>
+      </p:pic>
+      <p:sp>
+        <p:nvSpPr>
+          <p:cNvPr id="2" name="Notched Right Arrow 1">
+            <a:extLst>
+              <a:ext uri="{FF2B5EF4-FFF2-40B4-BE49-F238E27FC236}">
+                <a16:creationId xmlns:a16="http://schemas.microsoft.com/office/drawing/2014/main" id="{2CB91A70-96BD-834C-B79F-C3D2A28F4A20}"/>
+              </a:ext>
+            </a:extLst>
+          </p:cNvPr>
+          <p:cNvSpPr/>
+          <p:nvPr/>
+        </p:nvSpPr>
+        <p:spPr>
+          <a:xfrm>
+            <a:off x="4132691" y="2634834"/>
+            <a:ext cx="978408" cy="484632"/>
+          </a:xfrm>
+          <a:prstGeom prst="notchedRightArrow">
+            <a:avLst/>
+          </a:prstGeom>
+          <a:noFill/>
+          <a:ln w="9525">
+            <a:solidFill>
+              <a:schemeClr val="tx1">
+                <a:lumMod val="75000"/>
+                <a:lumOff val="25000"/>
+              </a:schemeClr>
+            </a:solidFill>
+          </a:ln>
+        </p:spPr>
+        <p:style>
+          <a:lnRef idx="2">
+            <a:schemeClr val="accent1">
+              <a:shade val="50000"/>
+            </a:schemeClr>
+          </a:lnRef>
+          <a:fillRef idx="1">
+            <a:schemeClr val="accent1"/>
+          </a:fillRef>
+          <a:effectRef idx="0">
+            <a:schemeClr val="accent1"/>
+          </a:effectRef>
+          <a:fontRef idx="minor">
+            <a:schemeClr val="lt1"/>
+          </a:fontRef>
+        </p:style>
+        <p:txBody>
+          <a:bodyPr rtlCol="0" anchor="ctr"/>
+          <a:lstStyle/>
+          <a:p>
+            <a:pPr algn="ctr"/>
+            <a:endParaRPr lang="en-US"/>
+          </a:p>
+        </p:txBody>
+      </p:sp>
+      <p:sp>
+        <p:nvSpPr>
+          <p:cNvPr id="5" name="TextBox 4">
+            <a:extLst>
+              <a:ext uri="{FF2B5EF4-FFF2-40B4-BE49-F238E27FC236}">
+                <a16:creationId xmlns:a16="http://schemas.microsoft.com/office/drawing/2014/main" id="{2385E19A-EECB-9749-81D5-8F7B5214E791}"/>
+              </a:ext>
+            </a:extLst>
+          </p:cNvPr>
+          <p:cNvSpPr txBox="1"/>
+          <p:nvPr/>
+        </p:nvSpPr>
+        <p:spPr>
+          <a:xfrm>
+            <a:off x="762000" y="1953214"/>
+            <a:ext cx="723275" cy="261610"/>
+          </a:xfrm>
+          <a:prstGeom prst="rect">
+            <a:avLst/>
+          </a:prstGeom>
+          <a:noFill/>
+        </p:spPr>
+        <p:txBody>
+          <a:bodyPr wrap="none" rtlCol="0">
+            <a:spAutoFit/>
+          </a:bodyPr>
+          <a:lstStyle/>
+          <a:p>
+            <a:r>
+              <a:rPr lang="ru-RU" sz="1100" dirty="0">
+                <a:solidFill>
+                  <a:schemeClr val="tx1">
+                    <a:lumMod val="85000"/>
+                    <a:lumOff val="15000"/>
+                  </a:schemeClr>
+                </a:solidFill>
+              </a:rPr>
+              <a:t>неделя 1</a:t>
+            </a:r>
+            <a:endParaRPr lang="en-US" sz="1100" dirty="0">
+              <a:solidFill>
+                <a:schemeClr val="tx1">
+                  <a:lumMod val="85000"/>
+                  <a:lumOff val="15000"/>
+                </a:schemeClr>
+              </a:solidFill>
+            </a:endParaRPr>
+          </a:p>
+        </p:txBody>
+      </p:sp>
+      <p:sp>
+        <p:nvSpPr>
+          <p:cNvPr id="8" name="TextBox 7">
+            <a:extLst>
+              <a:ext uri="{FF2B5EF4-FFF2-40B4-BE49-F238E27FC236}">
+                <a16:creationId xmlns:a16="http://schemas.microsoft.com/office/drawing/2014/main" id="{E4365ADB-D285-8540-BD5A-E321618898C1}"/>
+              </a:ext>
+            </a:extLst>
+          </p:cNvPr>
+          <p:cNvSpPr txBox="1"/>
+          <p:nvPr/>
+        </p:nvSpPr>
+        <p:spPr>
+          <a:xfrm>
+            <a:off x="5562600" y="1948755"/>
+            <a:ext cx="723275" cy="261610"/>
+          </a:xfrm>
+          <a:prstGeom prst="rect">
+            <a:avLst/>
+          </a:prstGeom>
+          <a:noFill/>
+        </p:spPr>
+        <p:txBody>
+          <a:bodyPr wrap="none" rtlCol="0">
+            <a:spAutoFit/>
+          </a:bodyPr>
+          <a:lstStyle/>
+          <a:p>
+            <a:r>
+              <a:rPr lang="ru-RU" sz="1100" dirty="0">
+                <a:solidFill>
+                  <a:schemeClr val="tx1">
+                    <a:lumMod val="85000"/>
+                    <a:lumOff val="15000"/>
+                  </a:schemeClr>
+                </a:solidFill>
+              </a:rPr>
+              <a:t>неделя 4</a:t>
+            </a:r>
+            <a:endParaRPr lang="en-US" sz="1100" dirty="0">
+              <a:solidFill>
+                <a:schemeClr val="tx1">
+                  <a:lumMod val="85000"/>
+                  <a:lumOff val="15000"/>
+                </a:schemeClr>
+              </a:solidFill>
+            </a:endParaRPr>
+          </a:p>
+        </p:txBody>
+      </p:sp>
+      <p:sp>
+        <p:nvSpPr>
+          <p:cNvPr id="10" name="TextBox 9">
+            <a:extLst>
+              <a:ext uri="{FF2B5EF4-FFF2-40B4-BE49-F238E27FC236}">
+                <a16:creationId xmlns:a16="http://schemas.microsoft.com/office/drawing/2014/main" id="{6C3F9A18-B682-474C-A8BC-9D38353A8B34}"/>
+              </a:ext>
+            </a:extLst>
+          </p:cNvPr>
+          <p:cNvSpPr txBox="1"/>
+          <p:nvPr/>
+        </p:nvSpPr>
+        <p:spPr>
+          <a:xfrm>
+            <a:off x="457200" y="4812776"/>
+            <a:ext cx="6400800" cy="246221"/>
+          </a:xfrm>
+          <a:prstGeom prst="rect">
+            <a:avLst/>
+          </a:prstGeom>
+          <a:noFill/>
+        </p:spPr>
+        <p:txBody>
+          <a:bodyPr wrap="square">
+            <a:spAutoFit/>
+          </a:bodyPr>
+          <a:lstStyle/>
+          <a:p>
+            <a:r>
+              <a:rPr lang="en-US" sz="1000" dirty="0">
+                <a:hlinkClick r:id="rId4"/>
+              </a:rPr>
+              <a:t>https://habr.com/ru/companies/glowbyte/articles/732024/</a:t>
+            </a:r>
+            <a:r>
+              <a:rPr lang="ru-RU" sz="1000" dirty="0"/>
+              <a:t> </a:t>
+            </a:r>
+            <a:endParaRPr lang="en-US" sz="1000" dirty="0"/>
+          </a:p>
+        </p:txBody>
+      </p:sp>
+    </p:spTree>
+    <p:extLst>
+      <p:ext uri="{BB962C8B-B14F-4D97-AF65-F5344CB8AC3E}">
+        <p14:creationId xmlns:p14="http://schemas.microsoft.com/office/powerpoint/2010/main" val="2407359377"/>
+      </p:ext>
+    </p:extLst>
+  </p:cSld>
+  <p:clrMapOvr>
+    <a:masterClrMapping/>
+  </p:clrMapOvr>
+</p:sld>
+</file>
+
+<file path=ppt/slides/slide12.xml><?xml version="1.0" encoding="utf-8"?>
+<p:sld xmlns:a="http://schemas.openxmlformats.org/drawingml/2006/main" xmlns:r="http://schemas.openxmlformats.org/officeDocument/2006/relationships" xmlns:p="http://schemas.openxmlformats.org/presentationml/2006/main">
+  <p:cSld>
+    <p:spTree>
+      <p:nvGrpSpPr>
+        <p:cNvPr id="1" name="Shape 479"/>
+        <p:cNvGrpSpPr/>
+        <p:nvPr/>
+      </p:nvGrpSpPr>
+      <p:grpSpPr>
+        <a:xfrm>
+          <a:off x="0" y="0"/>
+          <a:ext cx="0" cy="0"/>
+          <a:chOff x="0" y="0"/>
+          <a:chExt cx="0" cy="0"/>
+        </a:xfrm>
+      </p:grpSpPr>
+      <p:sp>
+        <p:nvSpPr>
+          <p:cNvPr id="480" name="Google Shape;480;p74"/>
+          <p:cNvSpPr txBox="1">
+            <a:spLocks noGrp="1"/>
+          </p:cNvSpPr>
+          <p:nvPr>
+            <p:ph type="title"/>
+          </p:nvPr>
+        </p:nvSpPr>
+        <p:spPr>
+          <a:xfrm>
+            <a:off x="651425" y="396394"/>
+            <a:ext cx="7706100" cy="4090800"/>
+          </a:xfrm>
+          <a:prstGeom prst="rect">
+            <a:avLst/>
+          </a:prstGeom>
+          <a:noFill/>
+          <a:ln>
+            <a:noFill/>
+          </a:ln>
+        </p:spPr>
+        <p:txBody>
+          <a:bodyPr spcFirstLastPara="1" wrap="square" lIns="91425" tIns="91425" rIns="91425" bIns="91425" anchor="ctr" anchorCtr="0">
+            <a:noAutofit/>
+          </a:bodyPr>
+          <a:lstStyle/>
+          <a:p>
+            <a:pPr marL="0" lvl="0" indent="0" algn="l" rtl="0">
+              <a:lnSpc>
+                <a:spcPct val="100000"/>
+              </a:lnSpc>
+              <a:spcBef>
+                <a:spcPts val="0"/>
+              </a:spcBef>
+              <a:spcAft>
+                <a:spcPts val="0"/>
+              </a:spcAft>
+              <a:buSzPts val="4600"/>
+              <a:buNone/>
+            </a:pPr>
+            <a:r>
+              <a:rPr lang="ru-RU" dirty="0"/>
+              <a:t>Множественное тестирование</a:t>
+            </a:r>
+          </a:p>
+        </p:txBody>
+      </p:sp>
+    </p:spTree>
+    <p:extLst>
+      <p:ext uri="{BB962C8B-B14F-4D97-AF65-F5344CB8AC3E}">
+        <p14:creationId xmlns:p14="http://schemas.microsoft.com/office/powerpoint/2010/main" val="4063190401"/>
+      </p:ext>
+    </p:extLst>
+  </p:cSld>
+  <p:clrMapOvr>
+    <a:masterClrMapping/>
+  </p:clrMapOvr>
+</p:sld>
+</file>
+
+<file path=ppt/slides/slide13.xml><?xml version="1.0" encoding="utf-8"?>
+<p:sld xmlns:a="http://schemas.openxmlformats.org/drawingml/2006/main" xmlns:r="http://schemas.openxmlformats.org/officeDocument/2006/relationships" xmlns:p="http://schemas.openxmlformats.org/presentationml/2006/main">
+  <p:cSld>
+    <p:spTree>
+      <p:nvGrpSpPr>
+        <p:cNvPr id="1" name=""/>
+        <p:cNvGrpSpPr/>
+        <p:nvPr/>
+      </p:nvGrpSpPr>
+      <p:grpSpPr>
+        <a:xfrm>
+          <a:off x="0" y="0"/>
+          <a:ext cx="0" cy="0"/>
+          <a:chOff x="0" y="0"/>
+          <a:chExt cx="0" cy="0"/>
+        </a:xfrm>
+      </p:grpSpPr>
+      <p:sp>
+        <p:nvSpPr>
+          <p:cNvPr id="3" name="Title 2">
+            <a:extLst>
+              <a:ext uri="{FF2B5EF4-FFF2-40B4-BE49-F238E27FC236}">
+                <a16:creationId xmlns:a16="http://schemas.microsoft.com/office/drawing/2014/main" id="{B6638231-D78E-9046-971E-9007915E5526}"/>
+              </a:ext>
+            </a:extLst>
+          </p:cNvPr>
+          <p:cNvSpPr>
+            <a:spLocks noGrp="1"/>
+          </p:cNvSpPr>
+          <p:nvPr>
+            <p:ph type="title"/>
+          </p:nvPr>
+        </p:nvSpPr>
+        <p:spPr/>
+        <p:txBody>
+          <a:bodyPr/>
+          <a:lstStyle/>
+          <a:p>
+            <a:r>
+              <a:rPr lang="ru-RU" dirty="0"/>
+              <a:t>Поправка </a:t>
+            </a:r>
+            <a:r>
+              <a:rPr lang="ru-RU" dirty="0" err="1"/>
+              <a:t>Бонферрони</a:t>
+            </a:r>
+            <a:endParaRPr lang="en-US" dirty="0"/>
+          </a:p>
+        </p:txBody>
+      </p:sp>
+      <p:pic>
+        <p:nvPicPr>
+          <p:cNvPr id="2050" name="Picture 2">
+            <a:extLst>
+              <a:ext uri="{FF2B5EF4-FFF2-40B4-BE49-F238E27FC236}">
+                <a16:creationId xmlns:a16="http://schemas.microsoft.com/office/drawing/2014/main" id="{173D0A9A-8B3F-874E-AE79-6A9DDFF05C67}"/>
+              </a:ext>
+            </a:extLst>
+          </p:cNvPr>
+          <p:cNvPicPr>
+            <a:picLocks noChangeAspect="1" noChangeArrowheads="1"/>
+          </p:cNvPicPr>
+          <p:nvPr/>
+        </p:nvPicPr>
+        <p:blipFill>
+          <a:blip r:embed="rId2">
+            <a:extLst>
+              <a:ext uri="{28A0092B-C50C-407E-A947-70E740481C1C}">
+                <a14:useLocalDpi xmlns:a14="http://schemas.microsoft.com/office/drawing/2010/main" val="0"/>
+              </a:ext>
+            </a:extLst>
+          </a:blip>
+          <a:srcRect/>
+          <a:stretch>
+            <a:fillRect/>
+          </a:stretch>
+        </p:blipFill>
+        <p:spPr bwMode="auto">
+          <a:xfrm>
+            <a:off x="860531" y="1425575"/>
+            <a:ext cx="3711469" cy="1908175"/>
+          </a:xfrm>
+          <a:prstGeom prst="rect">
+            <a:avLst/>
+          </a:prstGeom>
+          <a:noFill/>
+          <a:extLst>
+            <a:ext uri="{909E8E84-426E-40DD-AFC4-6F175D3DCCD1}">
+              <a14:hiddenFill xmlns:a14="http://schemas.microsoft.com/office/drawing/2010/main">
+                <a:solidFill>
+                  <a:srgbClr val="FFFFFF"/>
+                </a:solidFill>
+              </a14:hiddenFill>
+            </a:ext>
+          </a:extLst>
+        </p:spPr>
+      </p:pic>
+      <p:pic>
+        <p:nvPicPr>
+          <p:cNvPr id="2052" name="Picture 4">
+            <a:extLst>
+              <a:ext uri="{FF2B5EF4-FFF2-40B4-BE49-F238E27FC236}">
+                <a16:creationId xmlns:a16="http://schemas.microsoft.com/office/drawing/2014/main" id="{66B58F6B-D8E5-1C42-B6D4-903F8C0FE40F}"/>
+              </a:ext>
+            </a:extLst>
+          </p:cNvPr>
+          <p:cNvPicPr>
+            <a:picLocks noChangeAspect="1" noChangeArrowheads="1"/>
+          </p:cNvPicPr>
+          <p:nvPr/>
+        </p:nvPicPr>
+        <p:blipFill>
+          <a:blip r:embed="rId3">
+            <a:extLst>
+              <a:ext uri="{28A0092B-C50C-407E-A947-70E740481C1C}">
+                <a14:useLocalDpi xmlns:a14="http://schemas.microsoft.com/office/drawing/2010/main" val="0"/>
+              </a:ext>
+            </a:extLst>
+          </a:blip>
+          <a:srcRect/>
+          <a:stretch>
+            <a:fillRect/>
+          </a:stretch>
+        </p:blipFill>
+        <p:spPr bwMode="auto">
+          <a:xfrm>
+            <a:off x="4721328" y="1616076"/>
+            <a:ext cx="3388493" cy="1527175"/>
+          </a:xfrm>
+          <a:prstGeom prst="rect">
+            <a:avLst/>
+          </a:prstGeom>
+          <a:noFill/>
+          <a:extLst>
+            <a:ext uri="{909E8E84-426E-40DD-AFC4-6F175D3DCCD1}">
+              <a14:hiddenFill xmlns:a14="http://schemas.microsoft.com/office/drawing/2010/main">
+                <a:solidFill>
+                  <a:srgbClr val="FFFFFF"/>
+                </a:solidFill>
+              </a14:hiddenFill>
+            </a:ext>
+          </a:extLst>
+        </p:spPr>
+      </p:pic>
+      <mc:AlternateContent xmlns:mc="http://schemas.openxmlformats.org/markup-compatibility/2006" xmlns:a14="http://schemas.microsoft.com/office/drawing/2010/main">
+        <mc:Choice Requires="a14">
+          <p:sp>
+            <p:nvSpPr>
+              <p:cNvPr id="2" name="TextBox 1">
+                <a:extLst>
+                  <a:ext uri="{FF2B5EF4-FFF2-40B4-BE49-F238E27FC236}">
+                    <a16:creationId xmlns:a16="http://schemas.microsoft.com/office/drawing/2014/main" id="{51B6CE07-A0DB-9546-AB9B-D4E65E005603}"/>
+                  </a:ext>
+                </a:extLst>
+              </p:cNvPr>
+              <p:cNvSpPr txBox="1"/>
+              <p:nvPr/>
+            </p:nvSpPr>
+            <p:spPr>
+              <a:xfrm>
+                <a:off x="2362200" y="3790950"/>
+                <a:ext cx="1013034" cy="461473"/>
+              </a:xfrm>
+              <a:prstGeom prst="rect">
+                <a:avLst/>
+              </a:prstGeom>
+              <a:noFill/>
+            </p:spPr>
+            <p:txBody>
+              <a:bodyPr wrap="none" rtlCol="0">
+                <a:spAutoFit/>
+              </a:bodyPr>
+              <a:lstStyle/>
+              <a:p>
+                <a14:m>
+                  <m:oMath xmlns:m="http://schemas.openxmlformats.org/officeDocument/2006/math">
+                    <m:sSub>
+                      <m:sSubPr>
+                        <m:ctrlPr>
+                          <a:rPr lang="en-US" b="0" i="1" smtClean="0">
+                            <a:latin typeface="Cambria Math" panose="02040503050406030204" pitchFamily="18" charset="0"/>
+                          </a:rPr>
+                        </m:ctrlPr>
+                      </m:sSubPr>
+                      <m:e>
+                        <m:r>
+                          <a:rPr lang="en-US" b="0" i="1" smtClean="0">
+                            <a:latin typeface="Cambria Math" panose="02040503050406030204" pitchFamily="18" charset="0"/>
+                          </a:rPr>
+                          <m:t>𝑝</m:t>
+                        </m:r>
+                      </m:e>
+                      <m:sub>
+                        <m:r>
+                          <a:rPr lang="en-US" b="0" i="1" smtClean="0">
+                            <a:latin typeface="Cambria Math" panose="02040503050406030204" pitchFamily="18" charset="0"/>
+                          </a:rPr>
+                          <m:t>𝛼</m:t>
+                        </m:r>
+                      </m:sub>
+                    </m:sSub>
+                    <m:r>
+                      <a:rPr lang="en-US" b="0" i="1" smtClean="0">
+                        <a:latin typeface="Cambria Math" panose="02040503050406030204" pitchFamily="18" charset="0"/>
+                      </a:rPr>
+                      <m:t>→</m:t>
+                    </m:r>
+                    <m:f>
+                      <m:fPr>
+                        <m:ctrlPr>
+                          <a:rPr lang="en-US" b="0" i="1" smtClean="0">
+                            <a:latin typeface="Cambria Math" panose="02040503050406030204" pitchFamily="18" charset="0"/>
+                          </a:rPr>
+                        </m:ctrlPr>
+                      </m:fPr>
+                      <m:num>
+                        <m:sSub>
+                          <m:sSubPr>
+                            <m:ctrlPr>
+                              <a:rPr lang="en-US" b="0" i="1" smtClean="0">
+                                <a:latin typeface="Cambria Math" panose="02040503050406030204" pitchFamily="18" charset="0"/>
+                              </a:rPr>
+                            </m:ctrlPr>
+                          </m:sSubPr>
+                          <m:e>
+                            <m:r>
+                              <a:rPr lang="en-US" b="0" i="1" smtClean="0">
+                                <a:latin typeface="Cambria Math" panose="02040503050406030204" pitchFamily="18" charset="0"/>
+                              </a:rPr>
+                              <m:t>𝑝</m:t>
+                            </m:r>
+                          </m:e>
+                          <m:sub>
+                            <m:r>
+                              <a:rPr lang="en-US" b="0" i="1" smtClean="0">
+                                <a:latin typeface="Cambria Math" panose="02040503050406030204" pitchFamily="18" charset="0"/>
+                              </a:rPr>
+                              <m:t>𝛼</m:t>
+                            </m:r>
+                          </m:sub>
+                        </m:sSub>
+                      </m:num>
+                      <m:den>
+                        <m:r>
+                          <a:rPr lang="en-US" b="0" i="1" smtClean="0">
+                            <a:latin typeface="Cambria Math" panose="02040503050406030204" pitchFamily="18" charset="0"/>
+                          </a:rPr>
+                          <m:t>𝑛</m:t>
+                        </m:r>
+                      </m:den>
+                    </m:f>
+                  </m:oMath>
+                </a14:m>
+                <a:r>
+                  <a:rPr lang="en-US" dirty="0"/>
+                  <a:t> </a:t>
+                </a:r>
+              </a:p>
+            </p:txBody>
+          </p:sp>
+        </mc:Choice>
+        <mc:Fallback xmlns="">
+          <p:sp>
+            <p:nvSpPr>
+              <p:cNvPr id="2" name="TextBox 1">
+                <a:extLst>
+                  <a:ext uri="{FF2B5EF4-FFF2-40B4-BE49-F238E27FC236}">
+                    <a16:creationId xmlns:a16="http://schemas.microsoft.com/office/drawing/2014/main" id="{51B6CE07-A0DB-9546-AB9B-D4E65E005603}"/>
+                  </a:ext>
+                </a:extLst>
+              </p:cNvPr>
+              <p:cNvSpPr txBox="1">
+                <a:spLocks noRot="1" noChangeAspect="1" noMove="1" noResize="1" noEditPoints="1" noAdjustHandles="1" noChangeArrowheads="1" noChangeShapeType="1" noTextEdit="1"/>
+              </p:cNvSpPr>
+              <p:nvPr/>
+            </p:nvSpPr>
+            <p:spPr>
+              <a:xfrm>
+                <a:off x="2362200" y="3790950"/>
+                <a:ext cx="1013034" cy="461473"/>
+              </a:xfrm>
+              <a:prstGeom prst="rect">
+                <a:avLst/>
+              </a:prstGeom>
+              <a:blipFill>
+                <a:blip r:embed="rId4"/>
+                <a:stretch>
+                  <a:fillRect/>
+                </a:stretch>
+              </a:blipFill>
+            </p:spPr>
+            <p:txBody>
+              <a:bodyPr/>
+              <a:lstStyle/>
+              <a:p>
+                <a:r>
+                  <a:rPr lang="en-US">
+                    <a:noFill/>
+                  </a:rPr>
+                  <a:t> </a:t>
+                </a:r>
+              </a:p>
+            </p:txBody>
+          </p:sp>
+        </mc:Fallback>
+      </mc:AlternateContent>
+      <mc:AlternateContent xmlns:mc="http://schemas.openxmlformats.org/markup-compatibility/2006" xmlns:a14="http://schemas.microsoft.com/office/drawing/2010/main">
+        <mc:Choice Requires="a14">
+          <p:sp>
+            <p:nvSpPr>
+              <p:cNvPr id="5" name="TextBox 4">
+                <a:extLst>
+                  <a:ext uri="{FF2B5EF4-FFF2-40B4-BE49-F238E27FC236}">
+                    <a16:creationId xmlns:a16="http://schemas.microsoft.com/office/drawing/2014/main" id="{A30BE48C-91A3-4B47-9548-9D0A29A44091}"/>
+                  </a:ext>
+                </a:extLst>
+              </p:cNvPr>
+              <p:cNvSpPr txBox="1"/>
+              <p:nvPr/>
+            </p:nvSpPr>
+            <p:spPr>
+              <a:xfrm>
+                <a:off x="3429000" y="3837020"/>
+                <a:ext cx="3735125" cy="369332"/>
+              </a:xfrm>
+              <a:prstGeom prst="rect">
+                <a:avLst/>
+              </a:prstGeom>
+              <a:noFill/>
+            </p:spPr>
+            <p:txBody>
+              <a:bodyPr wrap="none" rtlCol="0">
+                <a:spAutoFit/>
+              </a:bodyPr>
+              <a:lstStyle/>
+              <a:p>
+                <a14:m>
+                  <m:oMath xmlns:m="http://schemas.openxmlformats.org/officeDocument/2006/math">
+                    <m:r>
+                      <a:rPr lang="en-US" b="0" i="1" smtClean="0">
+                        <a:latin typeface="Cambria Math" panose="02040503050406030204" pitchFamily="18" charset="0"/>
+                      </a:rPr>
+                      <m:t>𝑛</m:t>
+                    </m:r>
+                  </m:oMath>
+                </a14:m>
+                <a:r>
+                  <a:rPr lang="en-US" dirty="0"/>
+                  <a:t> – </a:t>
+                </a:r>
+                <a:r>
+                  <a:rPr lang="ru-RU" dirty="0"/>
+                  <a:t>количество сравниваемых групп</a:t>
+                </a:r>
+                <a:endParaRPr lang="en-US" dirty="0"/>
+              </a:p>
+            </p:txBody>
+          </p:sp>
+        </mc:Choice>
+        <mc:Fallback xmlns="">
+          <p:sp>
+            <p:nvSpPr>
+              <p:cNvPr id="5" name="TextBox 4">
+                <a:extLst>
+                  <a:ext uri="{FF2B5EF4-FFF2-40B4-BE49-F238E27FC236}">
+                    <a16:creationId xmlns:a16="http://schemas.microsoft.com/office/drawing/2014/main" id="{A30BE48C-91A3-4B47-9548-9D0A29A44091}"/>
+                  </a:ext>
+                </a:extLst>
+              </p:cNvPr>
+              <p:cNvSpPr txBox="1">
+                <a:spLocks noRot="1" noChangeAspect="1" noMove="1" noResize="1" noEditPoints="1" noAdjustHandles="1" noChangeArrowheads="1" noChangeShapeType="1" noTextEdit="1"/>
+              </p:cNvSpPr>
+              <p:nvPr/>
+            </p:nvSpPr>
+            <p:spPr>
+              <a:xfrm>
+                <a:off x="3429000" y="3837020"/>
+                <a:ext cx="3735125" cy="369332"/>
+              </a:xfrm>
+              <a:prstGeom prst="rect">
+                <a:avLst/>
+              </a:prstGeom>
+              <a:blipFill>
+                <a:blip r:embed="rId5"/>
+                <a:stretch>
+                  <a:fillRect t="-3226" r="-680" b="-22581"/>
+                </a:stretch>
+              </a:blipFill>
+            </p:spPr>
+            <p:txBody>
+              <a:bodyPr/>
+              <a:lstStyle/>
+              <a:p>
+                <a:r>
+                  <a:rPr lang="en-US">
+                    <a:noFill/>
+                  </a:rPr>
+                  <a:t> </a:t>
+                </a:r>
+              </a:p>
+            </p:txBody>
+          </p:sp>
+        </mc:Fallback>
+      </mc:AlternateContent>
+    </p:spTree>
+    <p:extLst>
+      <p:ext uri="{BB962C8B-B14F-4D97-AF65-F5344CB8AC3E}">
+        <p14:creationId xmlns:p14="http://schemas.microsoft.com/office/powerpoint/2010/main" val="2389834362"/>
+      </p:ext>
+    </p:extLst>
+  </p:cSld>
+  <p:clrMapOvr>
+    <a:masterClrMapping/>
+  </p:clrMapOvr>
+</p:sld>
+</file>
+
+<file path=ppt/slides/slide14.xml><?xml version="1.0" encoding="utf-8"?>
+<p:sld xmlns:a="http://schemas.openxmlformats.org/drawingml/2006/main" xmlns:r="http://schemas.openxmlformats.org/officeDocument/2006/relationships" xmlns:p="http://schemas.openxmlformats.org/presentationml/2006/main">
+  <p:cSld>
+    <p:spTree>
+      <p:nvGrpSpPr>
+        <p:cNvPr id="1" name="Shape 479"/>
+        <p:cNvGrpSpPr/>
+        <p:nvPr/>
+      </p:nvGrpSpPr>
+      <p:grpSpPr>
+        <a:xfrm>
+          <a:off x="0" y="0"/>
+          <a:ext cx="0" cy="0"/>
+          <a:chOff x="0" y="0"/>
+          <a:chExt cx="0" cy="0"/>
+        </a:xfrm>
+      </p:grpSpPr>
+      <p:sp>
+        <p:nvSpPr>
+          <p:cNvPr id="480" name="Google Shape;480;p74"/>
+          <p:cNvSpPr txBox="1">
+            <a:spLocks noGrp="1"/>
+          </p:cNvSpPr>
+          <p:nvPr>
+            <p:ph type="title"/>
+          </p:nvPr>
+        </p:nvSpPr>
+        <p:spPr>
+          <a:xfrm>
+            <a:off x="651425" y="396394"/>
+            <a:ext cx="7706100" cy="4090800"/>
+          </a:xfrm>
+          <a:prstGeom prst="rect">
+            <a:avLst/>
+          </a:prstGeom>
+          <a:noFill/>
+          <a:ln>
+            <a:noFill/>
+          </a:ln>
+        </p:spPr>
+        <p:txBody>
+          <a:bodyPr spcFirstLastPara="1" wrap="square" lIns="91425" tIns="91425" rIns="91425" bIns="91425" anchor="ctr" anchorCtr="0">
+            <a:noAutofit/>
+          </a:bodyPr>
+          <a:lstStyle/>
+          <a:p>
+            <a:pPr marL="0" lvl="0" indent="0" algn="l" rtl="0">
+              <a:lnSpc>
+                <a:spcPct val="100000"/>
+              </a:lnSpc>
+              <a:spcBef>
+                <a:spcPts val="0"/>
+              </a:spcBef>
+              <a:spcAft>
+                <a:spcPts val="0"/>
+              </a:spcAft>
+              <a:buSzPts val="4600"/>
+              <a:buNone/>
+            </a:pPr>
+            <a:r>
+              <a:rPr lang="ru-RU" dirty="0"/>
+              <a:t>Стратификация</a:t>
+            </a:r>
+          </a:p>
+        </p:txBody>
+      </p:sp>
+    </p:spTree>
+    <p:extLst>
+      <p:ext uri="{BB962C8B-B14F-4D97-AF65-F5344CB8AC3E}">
+        <p14:creationId xmlns:p14="http://schemas.microsoft.com/office/powerpoint/2010/main" val="3152197444"/>
+      </p:ext>
+    </p:extLst>
+  </p:cSld>
+  <p:clrMapOvr>
+    <a:masterClrMapping/>
+  </p:clrMapOvr>
+</p:sld>
+</file>
+
+<file path=ppt/slides/slide15.xml><?xml version="1.0" encoding="utf-8"?>
+<p:sld xmlns:a="http://schemas.openxmlformats.org/drawingml/2006/main" xmlns:r="http://schemas.openxmlformats.org/officeDocument/2006/relationships" xmlns:p="http://schemas.openxmlformats.org/presentationml/2006/main">
+  <p:cSld>
+    <p:spTree>
+      <p:nvGrpSpPr>
+        <p:cNvPr id="1" name=""/>
+        <p:cNvGrpSpPr/>
+        <p:nvPr/>
+      </p:nvGrpSpPr>
+      <p:grpSpPr>
+        <a:xfrm>
+          <a:off x="0" y="0"/>
+          <a:ext cx="0" cy="0"/>
+          <a:chOff x="0" y="0"/>
+          <a:chExt cx="0" cy="0"/>
+        </a:xfrm>
+      </p:grpSpPr>
+      <p:sp>
+        <p:nvSpPr>
+          <p:cNvPr id="3" name="Title 2">
+            <a:extLst>
+              <a:ext uri="{FF2B5EF4-FFF2-40B4-BE49-F238E27FC236}">
+                <a16:creationId xmlns:a16="http://schemas.microsoft.com/office/drawing/2014/main" id="{B6638231-D78E-9046-971E-9007915E5526}"/>
+              </a:ext>
+            </a:extLst>
+          </p:cNvPr>
+          <p:cNvSpPr>
+            <a:spLocks noGrp="1"/>
+          </p:cNvSpPr>
+          <p:nvPr>
+            <p:ph type="title"/>
+          </p:nvPr>
+        </p:nvSpPr>
+        <p:spPr/>
+        <p:txBody>
+          <a:bodyPr/>
+          <a:lstStyle/>
+          <a:p>
+            <a:r>
+              <a:rPr lang="ru-RU" dirty="0"/>
+              <a:t>Стратификация</a:t>
+            </a:r>
+            <a:endParaRPr lang="en-US" dirty="0"/>
+          </a:p>
+        </p:txBody>
+      </p:sp>
+      <p:sp>
+        <p:nvSpPr>
+          <p:cNvPr id="2" name="TextBox 1">
+            <a:extLst>
+              <a:ext uri="{FF2B5EF4-FFF2-40B4-BE49-F238E27FC236}">
+                <a16:creationId xmlns:a16="http://schemas.microsoft.com/office/drawing/2014/main" id="{991F081A-A1DB-DD4F-9F76-CAD13EC980FF}"/>
+              </a:ext>
+            </a:extLst>
+          </p:cNvPr>
+          <p:cNvSpPr txBox="1"/>
+          <p:nvPr/>
+        </p:nvSpPr>
+        <p:spPr>
+          <a:xfrm>
+            <a:off x="500551" y="1276350"/>
+            <a:ext cx="8520600" cy="3524042"/>
+          </a:xfrm>
+          <a:prstGeom prst="rect">
+            <a:avLst/>
+          </a:prstGeom>
+          <a:noFill/>
+        </p:spPr>
+        <p:txBody>
+          <a:bodyPr wrap="square" rtlCol="0">
+            <a:spAutoFit/>
+          </a:bodyPr>
+          <a:lstStyle/>
+          <a:p>
+            <a:pPr>
+              <a:spcAft>
+                <a:spcPts val="600"/>
+              </a:spcAft>
+            </a:pPr>
+            <a:r>
+              <a:rPr lang="ru-RU" sz="1600" dirty="0"/>
+              <a:t>У нас есть программа лояльности, в которой зарегистрированы не все пользователи нашего магазина. Поведение зарегистрированных пользователей может отличаться от поведения незарегистрированных. </a:t>
+            </a:r>
+            <a:br>
+              <a:rPr lang="en-US" sz="1600" dirty="0"/>
+            </a:br>
+            <a:r>
+              <a:rPr lang="ru-RU" sz="1600" dirty="0"/>
+              <a:t>Информацию о регистрации в программе лояльности можно использовать для повышения чувствительности эксперимента.</a:t>
+            </a:r>
+            <a:endParaRPr lang="en-US" sz="1600" dirty="0"/>
+          </a:p>
+          <a:p>
+            <a:pPr marL="285750" indent="-285750">
+              <a:spcAft>
+                <a:spcPts val="600"/>
+              </a:spcAft>
+              <a:buFont typeface="Arial" panose="020B0604020202020204" pitchFamily="34" charset="0"/>
+              <a:buChar char="•"/>
+            </a:pPr>
+            <a:r>
+              <a:rPr lang="ru-RU" sz="1600" b="1" dirty="0" err="1"/>
+              <a:t>Ковариата</a:t>
+            </a:r>
+            <a:r>
+              <a:rPr lang="ru-RU" sz="1600" dirty="0"/>
+              <a:t> - метрика, которая коррелирует с целевой метрикой, может быть измерена до эксперимента (строго говоря, нет) и не зависит от других экспериментов. В нашем случае факт регистрации в программе лояльности до эксперимента будет </a:t>
+            </a:r>
+            <a:r>
+              <a:rPr lang="ru-RU" sz="1600" dirty="0" err="1"/>
+              <a:t>ковариатой</a:t>
+            </a:r>
+            <a:r>
+              <a:rPr lang="ru-RU" sz="1600" dirty="0"/>
+              <a:t>.</a:t>
+            </a:r>
+          </a:p>
+          <a:p>
+            <a:pPr marL="285750" indent="-285750">
+              <a:spcAft>
+                <a:spcPts val="600"/>
+              </a:spcAft>
+              <a:buFont typeface="Arial" panose="020B0604020202020204" pitchFamily="34" charset="0"/>
+              <a:buChar char="•"/>
+            </a:pPr>
+            <a:r>
+              <a:rPr lang="ru-RU" sz="1600" b="1" dirty="0"/>
+              <a:t>Популяция </a:t>
+            </a:r>
+            <a:r>
+              <a:rPr lang="ru-RU" sz="1600" dirty="0"/>
+              <a:t>- все пользователи, на которых мы можем повлиять нашим экспериментом. Пусть в нашей популяции будет 10 тысяч активных пользователей.</a:t>
+            </a:r>
+          </a:p>
+          <a:p>
+            <a:pPr marL="285750" indent="-285750">
+              <a:spcAft>
+                <a:spcPts val="600"/>
+              </a:spcAft>
+              <a:buFont typeface="Arial" panose="020B0604020202020204" pitchFamily="34" charset="0"/>
+              <a:buChar char="•"/>
+            </a:pPr>
+            <a:r>
+              <a:rPr lang="ru-RU" sz="1600" dirty="0"/>
+              <a:t>С помощью </a:t>
+            </a:r>
+            <a:r>
+              <a:rPr lang="ru-RU" sz="1600" dirty="0" err="1"/>
+              <a:t>ковариат</a:t>
+            </a:r>
+            <a:r>
+              <a:rPr lang="ru-RU" sz="1600" dirty="0"/>
+              <a:t> можно разделить популяцию на непересекающиеся подмножества, которые будут обладать уникальным набором значений </a:t>
+            </a:r>
+            <a:r>
+              <a:rPr lang="ru-RU" sz="1600" dirty="0" err="1"/>
+              <a:t>ковариат</a:t>
+            </a:r>
+            <a:r>
+              <a:rPr lang="ru-RU" sz="1600" dirty="0"/>
+              <a:t>. Такие подмножества будем называть </a:t>
+            </a:r>
+            <a:r>
+              <a:rPr lang="ru-RU" sz="1600" b="1" dirty="0"/>
+              <a:t>стратами</a:t>
+            </a:r>
+            <a:r>
+              <a:rPr lang="ru-RU" sz="1600" dirty="0"/>
+              <a:t>.</a:t>
+            </a:r>
+            <a:endParaRPr lang="en-US" sz="1600" dirty="0"/>
+          </a:p>
+        </p:txBody>
+      </p:sp>
+    </p:spTree>
+    <p:extLst>
+      <p:ext uri="{BB962C8B-B14F-4D97-AF65-F5344CB8AC3E}">
+        <p14:creationId xmlns:p14="http://schemas.microsoft.com/office/powerpoint/2010/main" val="2609322878"/>
+      </p:ext>
+    </p:extLst>
+  </p:cSld>
+  <p:clrMapOvr>
+    <a:masterClrMapping/>
+  </p:clrMapOvr>
+</p:sld>
+</file>
+
+<file path=ppt/slides/slide16.xml><?xml version="1.0" encoding="utf-8"?>
+<p:sld xmlns:a="http://schemas.openxmlformats.org/drawingml/2006/main" xmlns:r="http://schemas.openxmlformats.org/officeDocument/2006/relationships" xmlns:p="http://schemas.openxmlformats.org/presentationml/2006/main">
+  <p:cSld>
+    <p:spTree>
+      <p:nvGrpSpPr>
+        <p:cNvPr id="1" name=""/>
+        <p:cNvGrpSpPr/>
+        <p:nvPr/>
+      </p:nvGrpSpPr>
+      <p:grpSpPr>
+        <a:xfrm>
+          <a:off x="0" y="0"/>
+          <a:ext cx="0" cy="0"/>
+          <a:chOff x="0" y="0"/>
+          <a:chExt cx="0" cy="0"/>
+        </a:xfrm>
+      </p:grpSpPr>
+      <p:sp>
+        <p:nvSpPr>
+          <p:cNvPr id="3" name="Title 2">
+            <a:extLst>
+              <a:ext uri="{FF2B5EF4-FFF2-40B4-BE49-F238E27FC236}">
+                <a16:creationId xmlns:a16="http://schemas.microsoft.com/office/drawing/2014/main" id="{B6638231-D78E-9046-971E-9007915E5526}"/>
+              </a:ext>
+            </a:extLst>
+          </p:cNvPr>
+          <p:cNvSpPr>
+            <a:spLocks noGrp="1"/>
+          </p:cNvSpPr>
+          <p:nvPr>
+            <p:ph type="title"/>
+          </p:nvPr>
+        </p:nvSpPr>
+        <p:spPr/>
+        <p:txBody>
+          <a:bodyPr/>
+          <a:lstStyle/>
+          <a:p>
+            <a:r>
+              <a:rPr lang="ru-RU" dirty="0"/>
+              <a:t>Стратификация</a:t>
+            </a:r>
+            <a:endParaRPr lang="en-US" dirty="0"/>
+          </a:p>
+        </p:txBody>
+      </p:sp>
+      <p:sp>
+        <p:nvSpPr>
+          <p:cNvPr id="2" name="TextBox 1">
+            <a:extLst>
+              <a:ext uri="{FF2B5EF4-FFF2-40B4-BE49-F238E27FC236}">
+                <a16:creationId xmlns:a16="http://schemas.microsoft.com/office/drawing/2014/main" id="{991F081A-A1DB-DD4F-9F76-CAD13EC980FF}"/>
+              </a:ext>
+            </a:extLst>
+          </p:cNvPr>
+          <p:cNvSpPr txBox="1"/>
+          <p:nvPr/>
+        </p:nvSpPr>
+        <p:spPr>
+          <a:xfrm>
+            <a:off x="500550" y="1123950"/>
+            <a:ext cx="8520600" cy="984885"/>
+          </a:xfrm>
+          <a:prstGeom prst="rect">
+            <a:avLst/>
+          </a:prstGeom>
+          <a:noFill/>
+        </p:spPr>
+        <p:txBody>
+          <a:bodyPr wrap="square" rtlCol="0">
+            <a:spAutoFit/>
+          </a:bodyPr>
+          <a:lstStyle/>
+          <a:p>
+            <a:pPr>
+              <a:spcAft>
+                <a:spcPts val="600"/>
+              </a:spcAft>
+            </a:pPr>
+            <a:r>
+              <a:rPr lang="ru-RU" sz="1600" dirty="0"/>
+              <a:t>В нашем примере будет две страты:</a:t>
+            </a:r>
+          </a:p>
+          <a:p>
+            <a:pPr marL="285750" indent="-285750">
+              <a:spcAft>
+                <a:spcPts val="600"/>
+              </a:spcAft>
+              <a:buFont typeface="Arial" panose="020B0604020202020204" pitchFamily="34" charset="0"/>
+              <a:buChar char="•"/>
+            </a:pPr>
+            <a:r>
+              <a:rPr lang="ru-RU" sz="1600" dirty="0"/>
+              <a:t>первая - кто не зарегистрирован в программе лояльности;</a:t>
+            </a:r>
+          </a:p>
+          <a:p>
+            <a:pPr marL="285750" indent="-285750">
+              <a:spcAft>
+                <a:spcPts val="600"/>
+              </a:spcAft>
+              <a:buFont typeface="Arial" panose="020B0604020202020204" pitchFamily="34" charset="0"/>
+              <a:buChar char="•"/>
+            </a:pPr>
+            <a:r>
+              <a:rPr lang="ru-RU" sz="1600" dirty="0"/>
+              <a:t>вторая - кто зарегистрирован в программе лояльности.</a:t>
+            </a:r>
+            <a:endParaRPr lang="en-US" sz="1600" dirty="0"/>
+          </a:p>
+        </p:txBody>
+      </p:sp>
+      <p:pic>
+        <p:nvPicPr>
+          <p:cNvPr id="1026" name="Picture 2">
+            <a:extLst>
+              <a:ext uri="{FF2B5EF4-FFF2-40B4-BE49-F238E27FC236}">
+                <a16:creationId xmlns:a16="http://schemas.microsoft.com/office/drawing/2014/main" id="{87F764DE-A5B6-6C42-AFF2-20C13E646FEB}"/>
+              </a:ext>
+            </a:extLst>
+          </p:cNvPr>
+          <p:cNvPicPr>
+            <a:picLocks noChangeAspect="1" noChangeArrowheads="1"/>
+          </p:cNvPicPr>
+          <p:nvPr/>
+        </p:nvPicPr>
+        <p:blipFill>
+          <a:blip r:embed="rId2">
+            <a:extLst>
+              <a:ext uri="{28A0092B-C50C-407E-A947-70E740481C1C}">
+                <a14:useLocalDpi xmlns:a14="http://schemas.microsoft.com/office/drawing/2010/main" val="0"/>
+              </a:ext>
+            </a:extLst>
+          </a:blip>
+          <a:srcRect/>
+          <a:stretch>
+            <a:fillRect/>
+          </a:stretch>
+        </p:blipFill>
+        <p:spPr bwMode="auto">
+          <a:xfrm>
+            <a:off x="609600" y="2108835"/>
+            <a:ext cx="4316412" cy="2877016"/>
+          </a:xfrm>
+          <a:prstGeom prst="rect">
+            <a:avLst/>
+          </a:prstGeom>
+          <a:noFill/>
+          <a:extLst>
+            <a:ext uri="{909E8E84-426E-40DD-AFC4-6F175D3DCCD1}">
+              <a14:hiddenFill xmlns:a14="http://schemas.microsoft.com/office/drawing/2010/main">
+                <a:solidFill>
+                  <a:srgbClr val="FFFFFF"/>
+                </a:solidFill>
+              </a14:hiddenFill>
+            </a:ext>
+          </a:extLst>
+        </p:spPr>
+      </p:pic>
+      <p:sp>
+        <p:nvSpPr>
+          <p:cNvPr id="6" name="TextBox 5">
+            <a:extLst>
+              <a:ext uri="{FF2B5EF4-FFF2-40B4-BE49-F238E27FC236}">
+                <a16:creationId xmlns:a16="http://schemas.microsoft.com/office/drawing/2014/main" id="{212B6EE1-21A4-8A48-B0E7-0BC8DE5D7E9B}"/>
+              </a:ext>
+            </a:extLst>
+          </p:cNvPr>
+          <p:cNvSpPr txBox="1"/>
+          <p:nvPr/>
+        </p:nvSpPr>
+        <p:spPr>
+          <a:xfrm>
+            <a:off x="5105400" y="2347013"/>
+            <a:ext cx="3542019" cy="1815882"/>
+          </a:xfrm>
+          <a:prstGeom prst="rect">
+            <a:avLst/>
+          </a:prstGeom>
+          <a:noFill/>
+        </p:spPr>
+        <p:txBody>
+          <a:bodyPr wrap="square">
+            <a:spAutoFit/>
+          </a:bodyPr>
+          <a:lstStyle/>
+          <a:p>
+            <a:r>
+              <a:rPr lang="ru-RU" sz="1600" dirty="0">
+                <a:solidFill>
+                  <a:srgbClr val="333333"/>
+                </a:solidFill>
+                <a:latin typeface="-apple-system"/>
+              </a:rPr>
+              <a:t>П</a:t>
+            </a:r>
+            <a:r>
+              <a:rPr lang="ru-RU" sz="1600" b="0" i="0" u="none" strike="noStrike" dirty="0">
+                <a:solidFill>
+                  <a:srgbClr val="333333"/>
+                </a:solidFill>
+                <a:effectLst/>
+                <a:latin typeface="-apple-system"/>
+              </a:rPr>
+              <a:t>ри случайном </a:t>
+            </a:r>
+            <a:r>
+              <a:rPr lang="ru-RU" sz="1600" b="0" i="0" u="none" strike="noStrike" dirty="0" err="1">
+                <a:solidFill>
+                  <a:srgbClr val="333333"/>
+                </a:solidFill>
+                <a:effectLst/>
+                <a:latin typeface="-apple-system"/>
+              </a:rPr>
+              <a:t>семплировании</a:t>
+            </a:r>
+            <a:r>
+              <a:rPr lang="ru-RU" sz="1600" b="0" i="0" u="none" strike="noStrike" dirty="0">
+                <a:solidFill>
+                  <a:srgbClr val="333333"/>
+                </a:solidFill>
+                <a:effectLst/>
+                <a:latin typeface="-apple-system"/>
+              </a:rPr>
+              <a:t> оценка вероятности ошибки первого рода равна 0.048, а при стратифицированном - 0.010.</a:t>
+            </a:r>
+          </a:p>
+          <a:p>
+            <a:endParaRPr lang="ru-RU" sz="1600" dirty="0">
+              <a:solidFill>
+                <a:srgbClr val="333333"/>
+              </a:solidFill>
+              <a:latin typeface="-apple-system"/>
+            </a:endParaRPr>
+          </a:p>
+          <a:p>
+            <a:r>
+              <a:rPr lang="ru-RU" sz="1600" b="1" dirty="0">
+                <a:solidFill>
+                  <a:srgbClr val="333333"/>
+                </a:solidFill>
+                <a:latin typeface="-apple-system"/>
+              </a:rPr>
+              <a:t>Стратификация уменьшила ошибку первого рода в 4 раза!</a:t>
+            </a:r>
+            <a:endParaRPr lang="en-US" sz="1600" b="1" dirty="0"/>
+          </a:p>
+        </p:txBody>
+      </p:sp>
+    </p:spTree>
+    <p:extLst>
+      <p:ext uri="{BB962C8B-B14F-4D97-AF65-F5344CB8AC3E}">
+        <p14:creationId xmlns:p14="http://schemas.microsoft.com/office/powerpoint/2010/main" val="188646838"/>
+      </p:ext>
+    </p:extLst>
+  </p:cSld>
+  <p:clrMapOvr>
+    <a:masterClrMapping/>
+  </p:clrMapOvr>
+</p:sld>
+</file>
+
+<file path=ppt/slides/slide17.xml><?xml version="1.0" encoding="utf-8"?>
+<p:sld xmlns:a="http://schemas.openxmlformats.org/drawingml/2006/main" xmlns:r="http://schemas.openxmlformats.org/officeDocument/2006/relationships" xmlns:p="http://schemas.openxmlformats.org/presentationml/2006/main">
+  <p:cSld>
+    <p:spTree>
+      <p:nvGrpSpPr>
+        <p:cNvPr id="1" name=""/>
+        <p:cNvGrpSpPr/>
+        <p:nvPr/>
+      </p:nvGrpSpPr>
+      <p:grpSpPr>
+        <a:xfrm>
+          <a:off x="0" y="0"/>
+          <a:ext cx="0" cy="0"/>
+          <a:chOff x="0" y="0"/>
+          <a:chExt cx="0" cy="0"/>
+        </a:xfrm>
+      </p:grpSpPr>
+      <p:sp>
+        <p:nvSpPr>
+          <p:cNvPr id="3" name="Title 2">
+            <a:extLst>
+              <a:ext uri="{FF2B5EF4-FFF2-40B4-BE49-F238E27FC236}">
+                <a16:creationId xmlns:a16="http://schemas.microsoft.com/office/drawing/2014/main" id="{B6638231-D78E-9046-971E-9007915E5526}"/>
+              </a:ext>
+            </a:extLst>
+          </p:cNvPr>
+          <p:cNvSpPr>
+            <a:spLocks noGrp="1"/>
+          </p:cNvSpPr>
+          <p:nvPr>
+            <p:ph type="title"/>
+          </p:nvPr>
+        </p:nvSpPr>
+        <p:spPr/>
+        <p:txBody>
+          <a:bodyPr/>
+          <a:lstStyle/>
+          <a:p>
+            <a:r>
+              <a:rPr lang="ru-RU" dirty="0"/>
+              <a:t>Стратификация</a:t>
+            </a:r>
+            <a:endParaRPr lang="en-US" dirty="0"/>
+          </a:p>
+        </p:txBody>
+      </p:sp>
+      <p:sp>
+        <p:nvSpPr>
+          <p:cNvPr id="2" name="TextBox 1">
+            <a:extLst>
+              <a:ext uri="{FF2B5EF4-FFF2-40B4-BE49-F238E27FC236}">
+                <a16:creationId xmlns:a16="http://schemas.microsoft.com/office/drawing/2014/main" id="{991F081A-A1DB-DD4F-9F76-CAD13EC980FF}"/>
+              </a:ext>
+            </a:extLst>
+          </p:cNvPr>
+          <p:cNvSpPr txBox="1"/>
+          <p:nvPr/>
+        </p:nvSpPr>
+        <p:spPr>
+          <a:xfrm>
+            <a:off x="500550" y="1047750"/>
+            <a:ext cx="8520600" cy="4078039"/>
+          </a:xfrm>
+          <a:prstGeom prst="rect">
+            <a:avLst/>
+          </a:prstGeom>
+          <a:noFill/>
+        </p:spPr>
+        <p:txBody>
+          <a:bodyPr wrap="square" rtlCol="0">
+            <a:spAutoFit/>
+          </a:bodyPr>
+          <a:lstStyle/>
+          <a:p>
+            <a:pPr>
+              <a:spcAft>
+                <a:spcPts val="600"/>
+              </a:spcAft>
+            </a:pPr>
+            <a:r>
+              <a:rPr lang="ru-RU" sz="1600" dirty="0"/>
+              <a:t>При стратифицированном </a:t>
+            </a:r>
+            <a:r>
+              <a:rPr lang="ru-RU" sz="1600" dirty="0" err="1"/>
+              <a:t>семплировании</a:t>
+            </a:r>
+            <a:r>
+              <a:rPr lang="ru-RU" sz="1600" dirty="0"/>
+              <a:t> мы не только делаем распределение средних более узким, но и снижаем дисперсию, зафиксировав количество страт в каждой группе. </a:t>
+            </a:r>
+          </a:p>
+          <a:p>
+            <a:pPr>
+              <a:spcAft>
+                <a:spcPts val="600"/>
+              </a:spcAft>
+            </a:pPr>
+            <a:r>
+              <a:rPr lang="ru-RU" sz="1600" dirty="0"/>
+              <a:t>Тест Стьюдента не знает о том, что мы </a:t>
+            </a:r>
+            <a:r>
+              <a:rPr lang="ru-RU" sz="1600" dirty="0" err="1"/>
+              <a:t>семплируем</a:t>
+            </a:r>
+            <a:r>
+              <a:rPr lang="ru-RU" sz="1600" dirty="0"/>
+              <a:t> данные не случайно, поэтому при подсчёте статистики используется завышенная оценка дисперсии.</a:t>
+            </a:r>
+          </a:p>
+          <a:p>
+            <a:pPr>
+              <a:spcAft>
+                <a:spcPts val="600"/>
+              </a:spcAft>
+            </a:pPr>
+            <a:endParaRPr lang="ru-RU" sz="1600" dirty="0"/>
+          </a:p>
+          <a:p>
+            <a:pPr>
+              <a:spcAft>
+                <a:spcPts val="600"/>
+              </a:spcAft>
+            </a:pPr>
+            <a:r>
+              <a:rPr lang="ru-RU" sz="1600" dirty="0"/>
+              <a:t>При вычислении </a:t>
+            </a:r>
+            <a:r>
+              <a:rPr lang="ru-RU" sz="1600" b="1" i="1" dirty="0"/>
+              <a:t>обычного среднего </a:t>
+            </a:r>
+            <a:r>
+              <a:rPr lang="ru-RU" sz="1600" dirty="0"/>
+              <a:t>мы делим суммарную выручку на общее количество пользователей. </a:t>
+            </a:r>
+          </a:p>
+          <a:p>
+            <a:pPr>
+              <a:spcAft>
+                <a:spcPts val="600"/>
+              </a:spcAft>
+            </a:pPr>
+            <a:r>
+              <a:rPr lang="ru-RU" sz="1600" dirty="0"/>
+              <a:t>При вычислении </a:t>
+            </a:r>
+            <a:r>
+              <a:rPr lang="ru-RU" sz="1600" b="1" i="1" dirty="0"/>
+              <a:t>стратифицированного среднего </a:t>
+            </a:r>
+            <a:r>
+              <a:rPr lang="ru-RU" sz="1600" dirty="0"/>
+              <a:t>мы считаем обычное среднее для каждой страты по отдельности, а затем вычисляем их взвешенную сумму, где вес страты - доля страты в популяции.</a:t>
+            </a:r>
+          </a:p>
+          <a:p>
+            <a:pPr>
+              <a:spcAft>
+                <a:spcPts val="600"/>
+              </a:spcAft>
+            </a:pPr>
+            <a:endParaRPr lang="ru-RU" sz="1600" dirty="0"/>
+          </a:p>
+          <a:p>
+            <a:pPr>
+              <a:spcAft>
+                <a:spcPts val="600"/>
+              </a:spcAft>
+            </a:pPr>
+            <a:r>
+              <a:rPr lang="ru-RU" sz="1600" dirty="0"/>
+              <a:t>Применение стратификации позволяет уменьшить размер выборки, при сохранении уровня значимости на прежнем уровне.</a:t>
+            </a:r>
+          </a:p>
+          <a:p>
+            <a:pPr>
+              <a:spcAft>
+                <a:spcPts val="600"/>
+              </a:spcAft>
+            </a:pPr>
+            <a:r>
+              <a:rPr lang="en-US" sz="1100" dirty="0">
+                <a:hlinkClick r:id="rId2"/>
+              </a:rPr>
+              <a:t>https://habr.com/ru/companies/X5Tech/articles/596279/</a:t>
+            </a:r>
+            <a:r>
+              <a:rPr lang="ru-RU" sz="1100" dirty="0"/>
+              <a:t> </a:t>
+            </a:r>
+            <a:endParaRPr lang="en-US" sz="1100" dirty="0"/>
+          </a:p>
+        </p:txBody>
+      </p:sp>
+    </p:spTree>
+    <p:extLst>
+      <p:ext uri="{BB962C8B-B14F-4D97-AF65-F5344CB8AC3E}">
+        <p14:creationId xmlns:p14="http://schemas.microsoft.com/office/powerpoint/2010/main" val="1527280980"/>
+      </p:ext>
+    </p:extLst>
+  </p:cSld>
+  <p:clrMapOvr>
+    <a:masterClrMapping/>
+  </p:clrMapOvr>
+</p:sld>
+</file>
+
+<file path=ppt/slides/slide18.xml><?xml version="1.0" encoding="utf-8"?>
+<p:sld xmlns:a="http://schemas.openxmlformats.org/drawingml/2006/main" xmlns:r="http://schemas.openxmlformats.org/officeDocument/2006/relationships" xmlns:p="http://schemas.openxmlformats.org/presentationml/2006/main">
+  <p:cSld>
+    <p:spTree>
+      <p:nvGrpSpPr>
+        <p:cNvPr id="1" name="Shape 479"/>
+        <p:cNvGrpSpPr/>
+        <p:nvPr/>
+      </p:nvGrpSpPr>
+      <p:grpSpPr>
+        <a:xfrm>
+          <a:off x="0" y="0"/>
+          <a:ext cx="0" cy="0"/>
+          <a:chOff x="0" y="0"/>
+          <a:chExt cx="0" cy="0"/>
+        </a:xfrm>
+      </p:grpSpPr>
+      <p:sp>
+        <p:nvSpPr>
+          <p:cNvPr id="480" name="Google Shape;480;p74"/>
+          <p:cNvSpPr txBox="1">
+            <a:spLocks noGrp="1"/>
+          </p:cNvSpPr>
+          <p:nvPr>
+            <p:ph type="title"/>
+          </p:nvPr>
+        </p:nvSpPr>
+        <p:spPr>
+          <a:xfrm>
+            <a:off x="651425" y="396394"/>
+            <a:ext cx="7706100" cy="4090800"/>
+          </a:xfrm>
+          <a:prstGeom prst="rect">
+            <a:avLst/>
+          </a:prstGeom>
+          <a:noFill/>
+          <a:ln>
+            <a:noFill/>
+          </a:ln>
+        </p:spPr>
+        <p:txBody>
+          <a:bodyPr spcFirstLastPara="1" wrap="square" lIns="91425" tIns="91425" rIns="91425" bIns="91425" anchor="ctr" anchorCtr="0">
+            <a:noAutofit/>
+          </a:bodyPr>
+          <a:lstStyle/>
+          <a:p>
+            <a:pPr marL="0" lvl="0" indent="0" algn="l" rtl="0">
+              <a:lnSpc>
+                <a:spcPct val="100000"/>
+              </a:lnSpc>
+              <a:spcBef>
+                <a:spcPts val="0"/>
+              </a:spcBef>
+              <a:spcAft>
+                <a:spcPts val="0"/>
+              </a:spcAft>
+              <a:buSzPts val="4600"/>
+              <a:buNone/>
+            </a:pPr>
+            <a:r>
+              <a:rPr lang="en-US" dirty="0"/>
+              <a:t>CUPED</a:t>
+            </a:r>
+            <a:endParaRPr lang="ru-RU" dirty="0"/>
+          </a:p>
+        </p:txBody>
+      </p:sp>
+    </p:spTree>
+    <p:extLst>
+      <p:ext uri="{BB962C8B-B14F-4D97-AF65-F5344CB8AC3E}">
+        <p14:creationId xmlns:p14="http://schemas.microsoft.com/office/powerpoint/2010/main" val="509895353"/>
+      </p:ext>
+    </p:extLst>
+  </p:cSld>
+  <p:clrMapOvr>
+    <a:masterClrMapping/>
+  </p:clrMapOvr>
+</p:sld>
+</file>
+
+<file path=ppt/slides/slide19.xml><?xml version="1.0" encoding="utf-8"?>
+<p:sld xmlns:a="http://schemas.openxmlformats.org/drawingml/2006/main" xmlns:r="http://schemas.openxmlformats.org/officeDocument/2006/relationships" xmlns:p="http://schemas.openxmlformats.org/presentationml/2006/main">
+  <p:cSld>
+    <p:spTree>
+      <p:nvGrpSpPr>
+        <p:cNvPr id="1" name=""/>
+        <p:cNvGrpSpPr/>
+        <p:nvPr/>
+      </p:nvGrpSpPr>
+      <p:grpSpPr>
+        <a:xfrm>
+          <a:off x="0" y="0"/>
+          <a:ext cx="0" cy="0"/>
+          <a:chOff x="0" y="0"/>
+          <a:chExt cx="0" cy="0"/>
+        </a:xfrm>
+      </p:grpSpPr>
+      <p:sp>
+        <p:nvSpPr>
+          <p:cNvPr id="3" name="Title 2">
+            <a:extLst>
+              <a:ext uri="{FF2B5EF4-FFF2-40B4-BE49-F238E27FC236}">
+                <a16:creationId xmlns:a16="http://schemas.microsoft.com/office/drawing/2014/main" id="{B6638231-D78E-9046-971E-9007915E5526}"/>
+              </a:ext>
+            </a:extLst>
+          </p:cNvPr>
+          <p:cNvSpPr>
+            <a:spLocks noGrp="1"/>
+          </p:cNvSpPr>
+          <p:nvPr>
+            <p:ph type="title"/>
+          </p:nvPr>
+        </p:nvSpPr>
+        <p:spPr/>
+        <p:txBody>
+          <a:bodyPr/>
+          <a:lstStyle/>
+          <a:p>
+            <a:r>
+              <a:rPr lang="en-US" dirty="0"/>
+              <a:t>CUPED </a:t>
+            </a:r>
+            <a:br>
+              <a:rPr lang="en-US" dirty="0"/>
+            </a:br>
+            <a:r>
+              <a:rPr lang="en-US" sz="2800" dirty="0"/>
+              <a:t>(Controlled-experiment Using Pre-Experiment Data)</a:t>
+            </a:r>
+            <a:endParaRPr lang="en-US" dirty="0"/>
+          </a:p>
+        </p:txBody>
+      </p:sp>
+      <p:pic>
+        <p:nvPicPr>
+          <p:cNvPr id="3074" name="Picture 2">
+            <a:extLst>
+              <a:ext uri="{FF2B5EF4-FFF2-40B4-BE49-F238E27FC236}">
+                <a16:creationId xmlns:a16="http://schemas.microsoft.com/office/drawing/2014/main" id="{E6DB7947-240C-3E46-A0BF-B78927B38073}"/>
+              </a:ext>
+            </a:extLst>
+          </p:cNvPr>
+          <p:cNvPicPr>
+            <a:picLocks noChangeAspect="1" noChangeArrowheads="1"/>
+          </p:cNvPicPr>
+          <p:nvPr/>
+        </p:nvPicPr>
+        <p:blipFill rotWithShape="1">
+          <a:blip r:embed="rId2">
+            <a:extLst>
+              <a:ext uri="{28A0092B-C50C-407E-A947-70E740481C1C}">
+                <a14:useLocalDpi xmlns:a14="http://schemas.microsoft.com/office/drawing/2010/main" val="0"/>
+              </a:ext>
+            </a:extLst>
+          </a:blip>
+          <a:srcRect t="11759" r="8331"/>
+          <a:stretch/>
+        </p:blipFill>
+        <p:spPr bwMode="auto">
+          <a:xfrm>
+            <a:off x="228600" y="2267364"/>
+            <a:ext cx="3960077" cy="2859000"/>
+          </a:xfrm>
+          <a:prstGeom prst="rect">
+            <a:avLst/>
+          </a:prstGeom>
+          <a:noFill/>
+          <a:extLst>
+            <a:ext uri="{909E8E84-426E-40DD-AFC4-6F175D3DCCD1}">
+              <a14:hiddenFill xmlns:a14="http://schemas.microsoft.com/office/drawing/2010/main">
+                <a:solidFill>
+                  <a:srgbClr val="FFFFFF"/>
+                </a:solidFill>
+              </a14:hiddenFill>
+            </a:ext>
+          </a:extLst>
+        </p:spPr>
+      </p:pic>
+      <p:sp>
+        <p:nvSpPr>
+          <p:cNvPr id="2" name="TextBox 1">
+            <a:extLst>
+              <a:ext uri="{FF2B5EF4-FFF2-40B4-BE49-F238E27FC236}">
+                <a16:creationId xmlns:a16="http://schemas.microsoft.com/office/drawing/2014/main" id="{D7607C1D-4AA5-E148-A454-77A31BB6E1FC}"/>
+              </a:ext>
+            </a:extLst>
+          </p:cNvPr>
+          <p:cNvSpPr txBox="1"/>
+          <p:nvPr/>
+        </p:nvSpPr>
+        <p:spPr>
+          <a:xfrm>
+            <a:off x="383322" y="1547509"/>
+            <a:ext cx="3960077" cy="577081"/>
+          </a:xfrm>
+          <a:prstGeom prst="rect">
+            <a:avLst/>
+          </a:prstGeom>
+          <a:noFill/>
+        </p:spPr>
+        <p:txBody>
+          <a:bodyPr wrap="square" rtlCol="0">
+            <a:spAutoFit/>
+          </a:bodyPr>
+          <a:lstStyle/>
+          <a:p>
+            <a:r>
+              <a:rPr lang="ru-RU" sz="1050" b="1" dirty="0"/>
+              <a:t>Среднее значение </a:t>
+            </a:r>
+            <a:r>
+              <a:rPr lang="ru-RU" sz="1050" dirty="0"/>
+              <a:t>суммарной выручки с пользователя в экспериментальной группе больше на 40 рублей. </a:t>
+            </a:r>
+          </a:p>
+          <a:p>
+            <a:r>
+              <a:rPr lang="ru-RU" sz="1050" b="1" dirty="0"/>
+              <a:t>Статистически значимых отличий нет</a:t>
+            </a:r>
+            <a:r>
+              <a:rPr lang="ru-RU" sz="1050" dirty="0"/>
+              <a:t>, </a:t>
+            </a:r>
+            <a:r>
+              <a:rPr lang="en-US" sz="1050" dirty="0"/>
+              <a:t>p-value </a:t>
+            </a:r>
+            <a:r>
+              <a:rPr lang="ru-RU" sz="1050" dirty="0"/>
+              <a:t>равно 0.87.</a:t>
+            </a:r>
+            <a:endParaRPr lang="en-US" sz="1050" dirty="0"/>
+          </a:p>
+        </p:txBody>
+      </p:sp>
+      <p:pic>
+        <p:nvPicPr>
+          <p:cNvPr id="3076" name="Picture 4">
+            <a:extLst>
+              <a:ext uri="{FF2B5EF4-FFF2-40B4-BE49-F238E27FC236}">
+                <a16:creationId xmlns:a16="http://schemas.microsoft.com/office/drawing/2014/main" id="{B3DD2534-3AA3-B048-A63E-95BEBEBF513D}"/>
+              </a:ext>
+            </a:extLst>
+          </p:cNvPr>
+          <p:cNvPicPr>
+            <a:picLocks noChangeAspect="1" noChangeArrowheads="1"/>
+          </p:cNvPicPr>
+          <p:nvPr/>
+        </p:nvPicPr>
+        <p:blipFill rotWithShape="1">
+          <a:blip r:embed="rId3">
+            <a:extLst>
+              <a:ext uri="{28A0092B-C50C-407E-A947-70E740481C1C}">
+                <a14:useLocalDpi xmlns:a14="http://schemas.microsoft.com/office/drawing/2010/main" val="0"/>
+              </a:ext>
+            </a:extLst>
+          </a:blip>
+          <a:srcRect t="11759" r="8331"/>
+          <a:stretch/>
+        </p:blipFill>
+        <p:spPr bwMode="auto">
+          <a:xfrm>
+            <a:off x="5061073" y="2257343"/>
+            <a:ext cx="3960077" cy="2859001"/>
+          </a:xfrm>
+          <a:prstGeom prst="rect">
+            <a:avLst/>
+          </a:prstGeom>
+          <a:noFill/>
+          <a:extLst>
+            <a:ext uri="{909E8E84-426E-40DD-AFC4-6F175D3DCCD1}">
+              <a14:hiddenFill xmlns:a14="http://schemas.microsoft.com/office/drawing/2010/main">
+                <a:solidFill>
+                  <a:srgbClr val="FFFFFF"/>
+                </a:solidFill>
+              </a14:hiddenFill>
+            </a:ext>
+          </a:extLst>
+        </p:spPr>
+      </p:pic>
+      <p:sp>
+        <p:nvSpPr>
+          <p:cNvPr id="6" name="TextBox 5">
+            <a:extLst>
+              <a:ext uri="{FF2B5EF4-FFF2-40B4-BE49-F238E27FC236}">
+                <a16:creationId xmlns:a16="http://schemas.microsoft.com/office/drawing/2014/main" id="{D78549FE-557E-7F44-B97A-3059E4897F94}"/>
+              </a:ext>
+            </a:extLst>
+          </p:cNvPr>
+          <p:cNvSpPr txBox="1"/>
+          <p:nvPr/>
+        </p:nvSpPr>
+        <p:spPr>
+          <a:xfrm>
+            <a:off x="5183923" y="1547509"/>
+            <a:ext cx="3960077" cy="577081"/>
+          </a:xfrm>
+          <a:prstGeom prst="rect">
+            <a:avLst/>
+          </a:prstGeom>
+          <a:noFill/>
+        </p:spPr>
+        <p:txBody>
+          <a:bodyPr wrap="square" rtlCol="0">
+            <a:spAutoFit/>
+          </a:bodyPr>
+          <a:lstStyle/>
+          <a:p>
+            <a:r>
+              <a:rPr lang="ru-RU" sz="1050" b="1" dirty="0"/>
+              <a:t>Приращение</a:t>
+            </a:r>
+            <a:r>
+              <a:rPr lang="ru-RU" sz="1050" dirty="0"/>
+              <a:t> суммарной выручки с пользователя в экспериментальной группе в среднем больше на 30 рублей. </a:t>
+            </a:r>
+          </a:p>
+          <a:p>
+            <a:r>
+              <a:rPr lang="ru-RU" sz="1050" b="1" dirty="0"/>
+              <a:t>Статистически значимые отличия</a:t>
+            </a:r>
+            <a:r>
+              <a:rPr lang="ru-RU" sz="1050" dirty="0"/>
+              <a:t>, </a:t>
+            </a:r>
+            <a:r>
+              <a:rPr lang="en-US" sz="1050" dirty="0"/>
+              <a:t>p-value </a:t>
+            </a:r>
+            <a:r>
+              <a:rPr lang="ru-RU" sz="1050" dirty="0"/>
+              <a:t>равно 0.007.</a:t>
+            </a:r>
+            <a:endParaRPr lang="en-US" sz="1050" dirty="0"/>
+          </a:p>
+        </p:txBody>
+      </p:sp>
+    </p:spTree>
+    <p:extLst>
+      <p:ext uri="{BB962C8B-B14F-4D97-AF65-F5344CB8AC3E}">
+        <p14:creationId xmlns:p14="http://schemas.microsoft.com/office/powerpoint/2010/main" val="2143076352"/>
+      </p:ext>
+    </p:extLst>
+  </p:cSld>
+  <p:clrMapOvr>
+    <a:masterClrMapping/>
+  </p:clrMapOvr>
+</p:sld>
+</file>
+
+<file path=ppt/slides/slide2.xml><?xml version="1.0" encoding="utf-8"?>
+<p:sld xmlns:a="http://schemas.openxmlformats.org/drawingml/2006/main" xmlns:r="http://schemas.openxmlformats.org/officeDocument/2006/relationships" xmlns:p="http://schemas.openxmlformats.org/presentationml/2006/main">
+  <p:cSld>
+    <p:spTree>
+      <p:nvGrpSpPr>
+        <p:cNvPr id="1" name=""/>
+        <p:cNvGrpSpPr/>
+        <p:nvPr/>
+      </p:nvGrpSpPr>
+      <p:grpSpPr>
+        <a:xfrm>
+          <a:off x="0" y="0"/>
+          <a:ext cx="0" cy="0"/>
+          <a:chOff x="0" y="0"/>
+          <a:chExt cx="0" cy="0"/>
+        </a:xfrm>
+      </p:grpSpPr>
+      <p:sp>
+        <p:nvSpPr>
+          <p:cNvPr id="2" name="object 2"/>
+          <p:cNvSpPr txBox="1">
+            <a:spLocks noGrp="1"/>
+          </p:cNvSpPr>
+          <p:nvPr>
+            <p:ph type="title"/>
+          </p:nvPr>
+        </p:nvSpPr>
+        <p:spPr>
+          <a:xfrm>
+            <a:off x="1708899" y="1009637"/>
+            <a:ext cx="3427729" cy="345440"/>
+          </a:xfrm>
+          <a:prstGeom prst="rect">
+            <a:avLst/>
+          </a:prstGeom>
+        </p:spPr>
+        <p:txBody>
+          <a:bodyPr vert="horz" wrap="square" lIns="0" tIns="12700" rIns="0" bIns="0" rtlCol="0">
+            <a:spAutoFit/>
+          </a:bodyPr>
+          <a:lstStyle/>
+          <a:p>
+            <a:pPr marL="12700">
+              <a:lnSpc>
+                <a:spcPct val="100000"/>
+              </a:lnSpc>
+              <a:spcBef>
+                <a:spcPts val="100"/>
+              </a:spcBef>
+            </a:pPr>
+            <a:r>
+              <a:rPr sz="2100" spc="-10" dirty="0"/>
+              <a:t>Проверить, </a:t>
+            </a:r>
+            <a:r>
+              <a:rPr sz="2100" spc="-25" dirty="0"/>
+              <a:t>идет</a:t>
+            </a:r>
+            <a:r>
+              <a:rPr sz="2100" spc="-10" dirty="0"/>
+              <a:t> </a:t>
+            </a:r>
+            <a:r>
+              <a:rPr sz="2100" spc="5" dirty="0"/>
+              <a:t>ли</a:t>
+            </a:r>
+            <a:r>
+              <a:rPr sz="2100" spc="-5" dirty="0"/>
+              <a:t> </a:t>
+            </a:r>
+            <a:r>
+              <a:rPr sz="2100" spc="-20" dirty="0"/>
+              <a:t>запись</a:t>
+            </a:r>
+            <a:endParaRPr sz="2100"/>
+          </a:p>
+        </p:txBody>
+      </p:sp>
+      <p:pic>
+        <p:nvPicPr>
+          <p:cNvPr id="3" name="object 3"/>
+          <p:cNvPicPr/>
+          <p:nvPr/>
+        </p:nvPicPr>
+        <p:blipFill>
+          <a:blip r:embed="rId2" cstate="print"/>
+          <a:stretch>
+            <a:fillRect/>
+          </a:stretch>
+        </p:blipFill>
+        <p:spPr>
+          <a:xfrm>
+            <a:off x="880825" y="1032407"/>
+            <a:ext cx="642317" cy="321158"/>
+          </a:xfrm>
+          <a:prstGeom prst="rect">
+            <a:avLst/>
+          </a:prstGeom>
+        </p:spPr>
+      </p:pic>
+      <p:pic>
+        <p:nvPicPr>
+          <p:cNvPr id="4" name="object 4"/>
+          <p:cNvPicPr/>
+          <p:nvPr/>
+        </p:nvPicPr>
+        <p:blipFill>
+          <a:blip r:embed="rId3" cstate="print"/>
+          <a:stretch>
+            <a:fillRect/>
+          </a:stretch>
+        </p:blipFill>
+        <p:spPr>
+          <a:xfrm>
+            <a:off x="872375" y="3520050"/>
+            <a:ext cx="525599" cy="525599"/>
+          </a:xfrm>
+          <a:prstGeom prst="rect">
+            <a:avLst/>
+          </a:prstGeom>
+        </p:spPr>
+      </p:pic>
+      <p:sp>
+        <p:nvSpPr>
+          <p:cNvPr id="5" name="object 5"/>
+          <p:cNvSpPr txBox="1"/>
+          <p:nvPr/>
+        </p:nvSpPr>
+        <p:spPr>
+          <a:xfrm>
+            <a:off x="839750" y="1810429"/>
+            <a:ext cx="5484850" cy="2197735"/>
+          </a:xfrm>
+          <a:prstGeom prst="rect">
+            <a:avLst/>
+          </a:prstGeom>
+        </p:spPr>
+        <p:txBody>
+          <a:bodyPr vert="horz" wrap="square" lIns="0" tIns="12700" rIns="0" bIns="0" rtlCol="0">
+            <a:spAutoFit/>
+          </a:bodyPr>
+          <a:lstStyle/>
+          <a:p>
+            <a:pPr marL="12700" marR="5080">
+              <a:lnSpc>
+                <a:spcPct val="100000"/>
+              </a:lnSpc>
+              <a:spcBef>
+                <a:spcPts val="100"/>
+              </a:spcBef>
+            </a:pPr>
+            <a:r>
+              <a:rPr sz="4000" b="1" spc="10" dirty="0">
+                <a:latin typeface="Roboto"/>
+                <a:cs typeface="Roboto"/>
+              </a:rPr>
+              <a:t>Меня</a:t>
+            </a:r>
+            <a:r>
+              <a:rPr sz="4000" b="1" spc="-40" dirty="0">
+                <a:latin typeface="Roboto"/>
+                <a:cs typeface="Roboto"/>
+              </a:rPr>
+              <a:t> </a:t>
+            </a:r>
+            <a:r>
+              <a:rPr sz="4000" b="1" spc="-20" dirty="0">
+                <a:latin typeface="Roboto"/>
+                <a:cs typeface="Roboto"/>
+              </a:rPr>
+              <a:t>хорошо</a:t>
+            </a:r>
+            <a:r>
+              <a:rPr sz="4000" b="1" spc="-30" dirty="0">
+                <a:latin typeface="Roboto"/>
+                <a:cs typeface="Roboto"/>
+              </a:rPr>
+              <a:t> </a:t>
+            </a:r>
+            <a:r>
+              <a:rPr sz="4000" b="1" spc="-35" dirty="0">
+                <a:latin typeface="Roboto"/>
+                <a:cs typeface="Roboto"/>
+              </a:rPr>
+              <a:t>видно </a:t>
+            </a:r>
+            <a:r>
+              <a:rPr sz="4000" b="1" spc="-980" dirty="0">
+                <a:latin typeface="Roboto"/>
+                <a:cs typeface="Roboto"/>
+              </a:rPr>
+              <a:t> </a:t>
+            </a:r>
+            <a:r>
+              <a:rPr sz="4000" b="1" spc="-10" dirty="0">
+                <a:latin typeface="Roboto"/>
+                <a:cs typeface="Roboto"/>
+              </a:rPr>
+              <a:t>&amp;&amp; </a:t>
+            </a:r>
+            <a:r>
+              <a:rPr sz="4000" b="1" dirty="0">
+                <a:latin typeface="Roboto"/>
+                <a:cs typeface="Roboto"/>
+              </a:rPr>
+              <a:t>слышно?</a:t>
+            </a:r>
+            <a:endParaRPr sz="4000" dirty="0">
+              <a:latin typeface="Roboto"/>
+              <a:cs typeface="Roboto"/>
+            </a:endParaRPr>
+          </a:p>
+          <a:p>
+            <a:pPr marL="760095" marR="1526540">
+              <a:lnSpc>
+                <a:spcPct val="100000"/>
+              </a:lnSpc>
+              <a:spcBef>
+                <a:spcPts val="3900"/>
+              </a:spcBef>
+            </a:pPr>
+            <a:r>
+              <a:rPr sz="1500" spc="-10" dirty="0">
+                <a:latin typeface="Roboto"/>
+                <a:cs typeface="Roboto"/>
+              </a:rPr>
+              <a:t>Ставим </a:t>
+            </a:r>
+            <a:r>
+              <a:rPr sz="1500" spc="-25" dirty="0">
+                <a:latin typeface="Roboto"/>
+                <a:cs typeface="Roboto"/>
+              </a:rPr>
+              <a:t>“+”, </a:t>
+            </a:r>
+            <a:r>
+              <a:rPr sz="1500" spc="10" dirty="0">
+                <a:latin typeface="Roboto"/>
+                <a:cs typeface="Roboto"/>
+              </a:rPr>
+              <a:t>если </a:t>
+            </a:r>
+            <a:r>
+              <a:rPr sz="1500" dirty="0">
+                <a:latin typeface="Roboto"/>
+                <a:cs typeface="Roboto"/>
+              </a:rPr>
+              <a:t>все </a:t>
+            </a:r>
+            <a:r>
+              <a:rPr sz="1500" spc="-10" dirty="0">
+                <a:latin typeface="Roboto"/>
+                <a:cs typeface="Roboto"/>
+              </a:rPr>
+              <a:t>хорошо </a:t>
+            </a:r>
+            <a:r>
+              <a:rPr sz="1500" spc="-360" dirty="0">
+                <a:latin typeface="Roboto"/>
+                <a:cs typeface="Roboto"/>
+              </a:rPr>
+              <a:t> </a:t>
+            </a:r>
+            <a:r>
+              <a:rPr sz="1500" spc="-105" dirty="0">
+                <a:latin typeface="Roboto"/>
+                <a:cs typeface="Roboto"/>
+              </a:rPr>
+              <a:t>“-”</a:t>
+            </a:r>
+            <a:r>
+              <a:rPr sz="1500" spc="-50" dirty="0">
+                <a:latin typeface="Roboto"/>
+                <a:cs typeface="Roboto"/>
+              </a:rPr>
+              <a:t>,</a:t>
+            </a:r>
+            <a:r>
+              <a:rPr sz="1500" spc="-5" dirty="0">
+                <a:latin typeface="Roboto"/>
+                <a:cs typeface="Roboto"/>
+              </a:rPr>
+              <a:t> </a:t>
+            </a:r>
+            <a:r>
+              <a:rPr sz="1500" spc="5" dirty="0">
+                <a:latin typeface="Roboto"/>
+                <a:cs typeface="Roboto"/>
+              </a:rPr>
+              <a:t>есл</a:t>
+            </a:r>
+            <a:r>
+              <a:rPr sz="1500" spc="15" dirty="0">
+                <a:latin typeface="Roboto"/>
+                <a:cs typeface="Roboto"/>
+              </a:rPr>
+              <a:t>и</a:t>
+            </a:r>
+            <a:r>
+              <a:rPr sz="1500" spc="-5" dirty="0">
+                <a:latin typeface="Roboto"/>
+                <a:cs typeface="Roboto"/>
+              </a:rPr>
+              <a:t> </a:t>
+            </a:r>
+            <a:r>
+              <a:rPr sz="1500" spc="-15" dirty="0">
+                <a:latin typeface="Roboto"/>
+                <a:cs typeface="Roboto"/>
+              </a:rPr>
+              <a:t>ест</a:t>
+            </a:r>
+            <a:r>
+              <a:rPr sz="1500" spc="-10" dirty="0">
+                <a:latin typeface="Roboto"/>
+                <a:cs typeface="Roboto"/>
+              </a:rPr>
+              <a:t>ь</a:t>
+            </a:r>
+            <a:r>
+              <a:rPr sz="1500" spc="-5" dirty="0">
+                <a:latin typeface="Roboto"/>
+                <a:cs typeface="Roboto"/>
+              </a:rPr>
+              <a:t> проблемы</a:t>
+            </a:r>
+            <a:endParaRPr sz="1500" dirty="0">
+              <a:latin typeface="Roboto"/>
+              <a:cs typeface="Roboto"/>
+            </a:endParaRPr>
+          </a:p>
+        </p:txBody>
+      </p:sp>
+    </p:spTree>
+  </p:cSld>
+  <p:clrMapOvr>
+    <a:masterClrMapping/>
+  </p:clrMapOvr>
+</p:sld>
+</file>
+
+<file path=ppt/slides/slide20.xml><?xml version="1.0" encoding="utf-8"?>
 <p:sld xmlns:a="http://schemas.openxmlformats.org/drawingml/2006/main" xmlns:r="http://schemas.openxmlformats.org/officeDocument/2006/relationships" xmlns:p="http://schemas.openxmlformats.org/presentationml/2006/main">
   <p:cSld>
     <p:spTree>
@@ -5898,7 +8603,7 @@
 </p:sld>
 </file>
 
-<file path=ppt/slides/slide12.xml><?xml version="1.0" encoding="utf-8"?>
+<file path=ppt/slides/slide21.xml><?xml version="1.0" encoding="utf-8"?>
 <p:sld xmlns:a="http://schemas.openxmlformats.org/drawingml/2006/main" xmlns:r="http://schemas.openxmlformats.org/officeDocument/2006/relationships" xmlns:p="http://schemas.openxmlformats.org/presentationml/2006/main">
   <p:cSld>
     <p:spTree>
@@ -5973,7 +8678,7 @@
 </p:sld>
 </file>
 
-<file path=ppt/slides/slide13.xml><?xml version="1.0" encoding="utf-8"?>
+<file path=ppt/slides/slide22.xml><?xml version="1.0" encoding="utf-8"?>
 <p:sld xmlns:a="http://schemas.openxmlformats.org/drawingml/2006/main" xmlns:r="http://schemas.openxmlformats.org/officeDocument/2006/relationships" xmlns:p="http://schemas.openxmlformats.org/presentationml/2006/main">
   <p:cSld>
     <p:spTree>
@@ -6045,14 +8750,14 @@
           <p:nvPr>
             <p:extLst>
               <p:ext uri="{D42A27DB-BD31-4B8C-83A1-F6EECF244321}">
-                <p14:modId xmlns:p14="http://schemas.microsoft.com/office/powerpoint/2010/main" val="2642399212"/>
+                <p14:modId xmlns:p14="http://schemas.microsoft.com/office/powerpoint/2010/main" val="610558428"/>
               </p:ext>
             </p:extLst>
           </p:nvPr>
         </p:nvGraphicFramePr>
         <p:xfrm>
           <a:off x="846750" y="1649963"/>
-          <a:ext cx="7239000" cy="1349472"/>
+          <a:ext cx="7239000" cy="1104108"/>
         </p:xfrm>
         <a:graphic>
           <a:graphicData uri="http://schemas.openxmlformats.org/drawingml/2006/table">
@@ -6180,7 +8885,7 @@
                         <a:rPr lang="ru-RU" sz="1400" dirty="0">
                           <a:sym typeface="Roboto"/>
                         </a:rPr>
-                        <a:t>Преобразуем данные к нормальному распределению с помощью преобразования Бокса-Кокса</a:t>
+                        <a:t>Построим байесовский А/Б тест </a:t>
                       </a:r>
                     </a:p>
                   </a:txBody>
@@ -6337,7 +9042,7 @@
                         <a:rPr lang="ru-RU" sz="1400" dirty="0">
                           <a:sym typeface="Roboto"/>
                         </a:rPr>
-                        <a:t>Проверим на независимость две числовые переменные</a:t>
+                        <a:t>Проверим А/Б тест в случае с несколькими группами</a:t>
                       </a:r>
                     </a:p>
                   </a:txBody>
@@ -6492,7 +9197,19 @@
                         <a:rPr lang="ru-RU" sz="1400" dirty="0">
                           <a:sym typeface="Roboto"/>
                         </a:rPr>
-                        <a:t>Проверим на независимость две категориальные переменные</a:t>
+                        <a:t>Поработаем с разбиением выборки и проверим </a:t>
+                      </a:r>
+                      <a:r>
+                        <a:rPr lang="en-US" sz="1400" dirty="0">
+                          <a:sym typeface="Roboto"/>
+                        </a:rPr>
+                        <a:t>CUPED </a:t>
+                      </a:r>
+                      <a:r>
+                        <a:rPr lang="ru-RU" sz="1400" dirty="0">
+                          <a:sym typeface="Roboto"/>
+                        </a:rPr>
+                        <a:t>метод</a:t>
                       </a:r>
                     </a:p>
                   </a:txBody>
@@ -6562,7 +9279,7 @@
 </p:sld>
 </file>
 
-<file path=ppt/slides/slide14.xml><?xml version="1.0" encoding="utf-8"?>
+<file path=ppt/slides/slide23.xml><?xml version="1.0" encoding="utf-8"?>
 <p:sld xmlns:a="http://schemas.openxmlformats.org/drawingml/2006/main" xmlns:r="http://schemas.openxmlformats.org/officeDocument/2006/relationships" xmlns:p="http://schemas.openxmlformats.org/presentationml/2006/main">
   <p:cSld>
     <p:spTree>
@@ -6950,7 +9667,7 @@
 </p:sld>
 </file>
 
-<file path=ppt/slides/slide15.xml><?xml version="1.0" encoding="utf-8"?>
+<file path=ppt/slides/slide24.xml><?xml version="1.0" encoding="utf-8"?>
 <p:sld xmlns:a="http://schemas.openxmlformats.org/drawingml/2006/main" xmlns:r="http://schemas.openxmlformats.org/officeDocument/2006/relationships" xmlns:p="http://schemas.openxmlformats.org/presentationml/2006/main">
   <p:cSld>
     <p:spTree>
@@ -7030,7 +9747,7 @@
         </p:spPr>
         <p:txBody>
           <a:bodyPr spcFirstLastPara="1" wrap="square" lIns="91425" tIns="91425" rIns="91425" bIns="91425" anchor="t" anchorCtr="0">
-            <a:normAutofit/>
+            <a:normAutofit fontScale="92500" lnSpcReduction="20000"/>
           </a:bodyPr>
           <a:lstStyle/>
           <a:p>
@@ -7058,12 +9775,22 @@
               <a:buAutoNum type="arabicPeriod"/>
             </a:pPr>
             <a:r>
-              <a:rPr lang="ru-RU" dirty="0"/>
-              <a:t>Статистика для всех. Сара </a:t>
-            </a:r>
-            <a:r>
-              <a:rPr lang="ru-RU" dirty="0" err="1"/>
-              <a:t>Бослаф</a:t>
+              <a:rPr lang="ru-RU" dirty="0">
+                <a:hlinkClick r:id="rId3"/>
+              </a:rPr>
+              <a:t>Стратификация. Как разбиение выборки повышает чувствительность </a:t>
+            </a:r>
+            <a:r>
+              <a:rPr lang="en-US" dirty="0">
+                <a:hlinkClick r:id="rId3"/>
+              </a:rPr>
+              <a:t>A/B </a:t>
+            </a:r>
+            <a:r>
+              <a:rPr lang="ru-RU" dirty="0">
+                <a:hlinkClick r:id="rId3"/>
+              </a:rPr>
+              <a:t>теста</a:t>
             </a:r>
             <a:endParaRPr lang="ru-RU" dirty="0"/>
           </a:p>
@@ -7079,9 +9806,18 @@
               <a:buAutoNum type="arabicPeriod"/>
             </a:pPr>
             <a:r>
-              <a:rPr lang="ru-RU" dirty="0"/>
-              <a:t>Статистика и котики. Владимир Савельев</a:t>
-            </a:r>
+              <a:rPr lang="ru-RU" dirty="0">
+                <a:hlinkClick r:id="rId4"/>
+              </a:rPr>
+              <a:t>А/Б тестирование с </a:t>
+            </a:r>
+            <a:r>
+              <a:rPr lang="en-US" dirty="0">
+                <a:hlinkClick r:id="rId4"/>
+              </a:rPr>
+              <a:t>CUPED</a:t>
+            </a:r>
+            <a:endParaRPr lang="ru-RU" dirty="0"/>
           </a:p>
           <a:p>
             <a:pPr marL="457200" indent="-311150" algn="l" rtl="0">
@@ -7095,12 +9831,10 @@
               <a:buAutoNum type="arabicPeriod"/>
             </a:pPr>
             <a:r>
-              <a:rPr lang="ru-RU" dirty="0"/>
-              <a:t>Голая статистика. Чарльз </a:t>
-            </a:r>
-            <a:r>
-              <a:rPr lang="ru-RU" dirty="0" err="1"/>
-              <a:t>Уилан</a:t>
+              <a:rPr lang="ru-RU" dirty="0">
+                <a:hlinkClick r:id="rId5"/>
+              </a:rPr>
+              <a:t>Проверка корректности А/Б тестов</a:t>
             </a:r>
             <a:endParaRPr lang="ru-RU" dirty="0"/>
           </a:p>
@@ -7116,20 +9850,10 @@
               <a:buAutoNum type="arabicPeriod"/>
             </a:pPr>
             <a:r>
-              <a:rPr lang="ru-RU" dirty="0"/>
-              <a:t>Как лгать при помощи статистики. </a:t>
-            </a:r>
-            <a:r>
-              <a:rPr lang="ru-RU" dirty="0" err="1"/>
-              <a:t>Дарелл</a:t>
-            </a:r>
-            <a:r>
-              <a:rPr lang="ru-RU" dirty="0"/>
-              <a:t> </a:t>
-            </a:r>
-            <a:r>
-              <a:rPr lang="ru-RU" dirty="0" err="1"/>
-              <a:t>Хафф</a:t>
+              <a:rPr lang="ru-RU" dirty="0">
+                <a:hlinkClick r:id="rId6"/>
+              </a:rPr>
+              <a:t>Определяем оптимальный размер групп при множественном А/Б тестировании</a:t>
             </a:r>
             <a:endParaRPr lang="ru-RU" dirty="0"/>
           </a:p>
@@ -7145,16 +9869,128 @@
               <a:buAutoNum type="arabicPeriod"/>
             </a:pPr>
             <a:r>
-              <a:rPr lang="ru-RU" dirty="0"/>
-              <a:t>Статистика. Шаг за шагом. Роберт А. </a:t>
-            </a:r>
-            <a:r>
-              <a:rPr lang="ru-RU" dirty="0" err="1"/>
-              <a:t>Доннелли</a:t>
-            </a:r>
-            <a:r>
-              <a:rPr lang="ru-RU" dirty="0"/>
-              <a:t> - мл</a:t>
+              <a:rPr lang="en-US" dirty="0">
+                <a:hlinkClick r:id="rId7"/>
+              </a:rPr>
+              <a:t>ML-</a:t>
+            </a:r>
+            <a:r>
+              <a:rPr lang="ru-RU" dirty="0">
+                <a:hlinkClick r:id="rId7"/>
+              </a:rPr>
+              <a:t>критерии для </a:t>
+            </a:r>
+            <a:r>
+              <a:rPr lang="en-US" dirty="0">
+                <a:hlinkClick r:id="rId7"/>
+              </a:rPr>
+              <a:t>A/B-</a:t>
+            </a:r>
+            <a:r>
+              <a:rPr lang="ru-RU" dirty="0">
+                <a:hlinkClick r:id="rId7"/>
+              </a:rPr>
+              <a:t>тестов</a:t>
+            </a:r>
+            <a:endParaRPr lang="ru-RU" dirty="0"/>
+          </a:p>
+          <a:p>
+            <a:pPr marL="457200" indent="-311150" algn="l" rtl="0">
+              <a:lnSpc>
+                <a:spcPct val="100000"/>
+              </a:lnSpc>
+              <a:spcAft>
+                <a:spcPts val="1200"/>
+              </a:spcAft>
+              <a:buSzPct val="100000"/>
+              <a:buAutoNum type="arabicPeriod"/>
+            </a:pPr>
+            <a:r>
+              <a:rPr lang="ru-RU" dirty="0">
+                <a:hlinkClick r:id="rId8"/>
+              </a:rPr>
+              <a:t>Шесть причин, почему ваши </a:t>
+            </a:r>
+            <a:r>
+              <a:rPr lang="en-GB" dirty="0">
+                <a:hlinkClick r:id="rId8"/>
+              </a:rPr>
+              <a:t>A/B-</a:t>
+            </a:r>
+            <a:r>
+              <a:rPr lang="ru-RU" dirty="0">
+                <a:hlinkClick r:id="rId8"/>
+              </a:rPr>
+              <a:t>тесты не работают</a:t>
+            </a:r>
+            <a:endParaRPr lang="ru-RU" dirty="0"/>
+          </a:p>
+          <a:p>
+            <a:pPr marL="457200" indent="-311150" algn="l" rtl="0">
+              <a:lnSpc>
+                <a:spcPct val="100000"/>
+              </a:lnSpc>
+              <a:spcAft>
+                <a:spcPts val="1200"/>
+              </a:spcAft>
+              <a:buSzPct val="100000"/>
+              <a:buAutoNum type="arabicPeriod"/>
+            </a:pPr>
+            <a:r>
+              <a:rPr lang="ru-RU" dirty="0">
+                <a:hlinkClick r:id="rId9"/>
+              </a:rPr>
+              <a:t>Множественные эксперименты: теория и практика</a:t>
+            </a:r>
+            <a:endParaRPr lang="ru-RU" dirty="0"/>
+          </a:p>
+          <a:p>
+            <a:pPr marL="457200" indent="-311150" algn="l" rtl="0">
+              <a:lnSpc>
+                <a:spcPct val="100000"/>
+              </a:lnSpc>
+              <a:spcAft>
+                <a:spcPts val="1200"/>
+              </a:spcAft>
+              <a:buSzPct val="100000"/>
+              <a:buAutoNum type="arabicPeriod"/>
+            </a:pPr>
+            <a:r>
+              <a:rPr lang="ru-RU" dirty="0">
+                <a:hlinkClick r:id="rId10"/>
+              </a:rPr>
+              <a:t>Подглядывание в </a:t>
+            </a:r>
+            <a:r>
+              <a:rPr lang="en-GB" dirty="0">
+                <a:hlinkClick r:id="rId10"/>
+              </a:rPr>
+              <a:t>A/B </a:t>
+            </a:r>
+            <a:r>
+              <a:rPr lang="ru-RU" dirty="0">
+                <a:hlinkClick r:id="rId10"/>
+              </a:rPr>
+              <a:t>тестах: как не потерять достоверность данных</a:t>
+            </a:r>
+            <a:endParaRPr lang="ru-RU" dirty="0"/>
+          </a:p>
+          <a:p>
+            <a:pPr marL="457200" indent="-311150" algn="l" rtl="0">
+              <a:lnSpc>
+                <a:spcPct val="100000"/>
+              </a:lnSpc>
+              <a:spcAft>
+                <a:spcPts val="1200"/>
+              </a:spcAft>
+              <a:buSzPct val="100000"/>
+              <a:buAutoNum type="arabicPeriod"/>
+            </a:pPr>
+            <a:r>
+              <a:rPr lang="ru-RU" dirty="0">
+                <a:hlinkClick r:id="rId11"/>
+              </a:rPr>
+              <a:t>Байесовский подход к АБ тестированию</a:t>
             </a:r>
             <a:endParaRPr lang="en-GB" dirty="0"/>
           </a:p>
@@ -7168,7 +10004,7 @@
 </p:sld>
 </file>
 
-<file path=ppt/slides/slide16.xml><?xml version="1.0" encoding="utf-8"?>
+<file path=ppt/slides/slide25.xml><?xml version="1.0" encoding="utf-8"?>
 <p:sld xmlns:a="http://schemas.openxmlformats.org/drawingml/2006/main" xmlns:r="http://schemas.openxmlformats.org/officeDocument/2006/relationships" xmlns:p="http://schemas.openxmlformats.org/presentationml/2006/main">
   <p:cSld>
     <p:spTree>
@@ -7248,7 +10084,7 @@
 </p:sld>
 </file>
 
-<file path=ppt/slides/slide17.xml><?xml version="1.0" encoding="utf-8"?>
+<file path=ppt/slides/slide26.xml><?xml version="1.0" encoding="utf-8"?>
 <p:sld xmlns:a="http://schemas.openxmlformats.org/drawingml/2006/main" xmlns:r="http://schemas.openxmlformats.org/officeDocument/2006/relationships" xmlns:p="http://schemas.openxmlformats.org/presentationml/2006/main">
   <p:cSld>
     <p:spTree>
@@ -7549,7 +10385,7 @@
 </p:sld>
 </file>
 
-<file path=ppt/slides/slide18.xml><?xml version="1.0" encoding="utf-8"?>
+<file path=ppt/slides/slide27.xml><?xml version="1.0" encoding="utf-8"?>
 <p:sld xmlns:a="http://schemas.openxmlformats.org/drawingml/2006/main" xmlns:r="http://schemas.openxmlformats.org/officeDocument/2006/relationships" xmlns:p="http://schemas.openxmlformats.org/presentationml/2006/main">
   <p:cSld>
     <p:spTree>
@@ -7668,7 +10504,7 @@
 </p:sld>
 </file>
 
-<file path=ppt/slides/slide19.xml><?xml version="1.0" encoding="utf-8"?>
+<file path=ppt/slides/slide28.xml><?xml version="1.0" encoding="utf-8"?>
 <p:sld xmlns:a="http://schemas.openxmlformats.org/drawingml/2006/main" xmlns:r="http://schemas.openxmlformats.org/officeDocument/2006/relationships" xmlns:p="http://schemas.openxmlformats.org/presentationml/2006/main">
   <p:cSld>
     <p:spTree>
@@ -7823,7 +10659,7 @@
               <a:rPr lang="ru-RU" sz="1600" dirty="0">
                 <a:latin typeface="+mj-lt"/>
               </a:rPr>
-              <a:t>А/Б тесты - практика</a:t>
+              <a:t>Что там дальше?</a:t>
             </a:r>
             <a:endParaRPr dirty="0">
               <a:latin typeface="+mj-lt"/>
@@ -8367,347 +11203,6 @@
         <p14:creationId xmlns:p14="http://schemas.microsoft.com/office/powerpoint/2010/main" val="706987243"/>
       </p:ext>
     </p:extLst>
-  </p:cSld>
-  <p:clrMapOvr>
-    <a:masterClrMapping/>
-  </p:clrMapOvr>
-</p:sld>
-</file>
-
-<file path=ppt/slides/slide2.xml><?xml version="1.0" encoding="utf-8"?>
-<p:sld xmlns:a="http://schemas.openxmlformats.org/drawingml/2006/main" xmlns:r="http://schemas.openxmlformats.org/officeDocument/2006/relationships" xmlns:p="http://schemas.openxmlformats.org/presentationml/2006/main">
-  <p:cSld>
-    <p:spTree>
-      <p:nvGrpSpPr>
-        <p:cNvPr id="1" name=""/>
-        <p:cNvGrpSpPr/>
-        <p:nvPr/>
-      </p:nvGrpSpPr>
-      <p:grpSpPr>
-        <a:xfrm>
-          <a:off x="0" y="0"/>
-          <a:ext cx="0" cy="0"/>
-          <a:chOff x="0" y="0"/>
-          <a:chExt cx="0" cy="0"/>
-        </a:xfrm>
-      </p:grpSpPr>
-      <p:sp>
-        <p:nvSpPr>
-          <p:cNvPr id="2" name="object 2"/>
-          <p:cNvSpPr txBox="1">
-            <a:spLocks noGrp="1"/>
-          </p:cNvSpPr>
-          <p:nvPr>
-            <p:ph type="title"/>
-          </p:nvPr>
-        </p:nvSpPr>
-        <p:spPr>
-          <a:xfrm>
-            <a:off x="1708899" y="1009637"/>
-            <a:ext cx="3427729" cy="345440"/>
-          </a:xfrm>
-          <a:prstGeom prst="rect">
-            <a:avLst/>
-          </a:prstGeom>
-        </p:spPr>
-        <p:txBody>
-          <a:bodyPr vert="horz" wrap="square" lIns="0" tIns="12700" rIns="0" bIns="0" rtlCol="0">
-            <a:spAutoFit/>
-          </a:bodyPr>
-          <a:lstStyle/>
-          <a:p>
-            <a:pPr marL="12700">
-              <a:lnSpc>
-                <a:spcPct val="100000"/>
-              </a:lnSpc>
-              <a:spcBef>
-                <a:spcPts val="100"/>
-              </a:spcBef>
-            </a:pPr>
-            <a:r>
-              <a:rPr sz="2100" spc="-10" dirty="0"/>
-              <a:t>Проверить, </a:t>
-            </a:r>
-            <a:r>
-              <a:rPr sz="2100" spc="-25" dirty="0"/>
-              <a:t>идет</a:t>
-            </a:r>
-            <a:r>
-              <a:rPr sz="2100" spc="-10" dirty="0"/>
-              <a:t> </a:t>
-            </a:r>
-            <a:r>
-              <a:rPr sz="2100" spc="5" dirty="0"/>
-              <a:t>ли</a:t>
-            </a:r>
-            <a:r>
-              <a:rPr sz="2100" spc="-5" dirty="0"/>
-              <a:t> </a:t>
-            </a:r>
-            <a:r>
-              <a:rPr sz="2100" spc="-20" dirty="0"/>
-              <a:t>запись</a:t>
-            </a:r>
-            <a:endParaRPr sz="2100"/>
-          </a:p>
-        </p:txBody>
-      </p:sp>
-      <p:pic>
-        <p:nvPicPr>
-          <p:cNvPr id="3" name="object 3"/>
-          <p:cNvPicPr/>
-          <p:nvPr/>
-        </p:nvPicPr>
-        <p:blipFill>
-          <a:blip r:embed="rId2" cstate="print"/>
-          <a:stretch>
-            <a:fillRect/>
-          </a:stretch>
-        </p:blipFill>
-        <p:spPr>
-          <a:xfrm>
-            <a:off x="880825" y="1032407"/>
-            <a:ext cx="642317" cy="321158"/>
-          </a:xfrm>
-          <a:prstGeom prst="rect">
-            <a:avLst/>
-          </a:prstGeom>
-        </p:spPr>
-      </p:pic>
-      <p:pic>
-        <p:nvPicPr>
-          <p:cNvPr id="4" name="object 4"/>
-          <p:cNvPicPr/>
-          <p:nvPr/>
-        </p:nvPicPr>
-        <p:blipFill>
-          <a:blip r:embed="rId3" cstate="print"/>
-          <a:stretch>
-            <a:fillRect/>
-          </a:stretch>
-        </p:blipFill>
-        <p:spPr>
-          <a:xfrm>
-            <a:off x="872375" y="3520050"/>
-            <a:ext cx="525599" cy="525599"/>
-          </a:xfrm>
-          <a:prstGeom prst="rect">
-            <a:avLst/>
-          </a:prstGeom>
-        </p:spPr>
-      </p:pic>
-      <p:sp>
-        <p:nvSpPr>
-          <p:cNvPr id="5" name="object 5"/>
-          <p:cNvSpPr txBox="1"/>
-          <p:nvPr/>
-        </p:nvSpPr>
-        <p:spPr>
-          <a:xfrm>
-            <a:off x="839750" y="1810429"/>
-            <a:ext cx="5484850" cy="2197735"/>
-          </a:xfrm>
-          <a:prstGeom prst="rect">
-            <a:avLst/>
-          </a:prstGeom>
-        </p:spPr>
-        <p:txBody>
-          <a:bodyPr vert="horz" wrap="square" lIns="0" tIns="12700" rIns="0" bIns="0" rtlCol="0">
-            <a:spAutoFit/>
-          </a:bodyPr>
-          <a:lstStyle/>
-          <a:p>
-            <a:pPr marL="12700" marR="5080">
-              <a:lnSpc>
-                <a:spcPct val="100000"/>
-              </a:lnSpc>
-              <a:spcBef>
-                <a:spcPts val="100"/>
-              </a:spcBef>
-            </a:pPr>
-            <a:r>
-              <a:rPr sz="4000" b="1" spc="10" dirty="0">
-                <a:latin typeface="Roboto"/>
-                <a:cs typeface="Roboto"/>
-              </a:rPr>
-              <a:t>Меня</a:t>
-            </a:r>
-            <a:r>
-              <a:rPr sz="4000" b="1" spc="-40" dirty="0">
-                <a:latin typeface="Roboto"/>
-                <a:cs typeface="Roboto"/>
-              </a:rPr>
-              <a:t> </a:t>
-            </a:r>
-            <a:r>
-              <a:rPr sz="4000" b="1" spc="-20" dirty="0">
-                <a:latin typeface="Roboto"/>
-                <a:cs typeface="Roboto"/>
-              </a:rPr>
-              <a:t>хорошо</a:t>
-            </a:r>
-            <a:r>
-              <a:rPr sz="4000" b="1" spc="-30" dirty="0">
-                <a:latin typeface="Roboto"/>
-                <a:cs typeface="Roboto"/>
-              </a:rPr>
-              <a:t> </a:t>
-            </a:r>
-            <a:r>
-              <a:rPr sz="4000" b="1" spc="-35" dirty="0">
-                <a:latin typeface="Roboto"/>
-                <a:cs typeface="Roboto"/>
-              </a:rPr>
-              <a:t>видно </a:t>
-            </a:r>
-            <a:r>
-              <a:rPr sz="4000" b="1" spc="-980" dirty="0">
-                <a:latin typeface="Roboto"/>
-                <a:cs typeface="Roboto"/>
-              </a:rPr>
-              <a:t> </a:t>
-            </a:r>
-            <a:r>
-              <a:rPr sz="4000" b="1" spc="-10" dirty="0">
-                <a:latin typeface="Roboto"/>
-                <a:cs typeface="Roboto"/>
-              </a:rPr>
-              <a:t>&amp;&amp; </a:t>
-            </a:r>
-            <a:r>
-              <a:rPr sz="4000" b="1" dirty="0">
-                <a:latin typeface="Roboto"/>
-                <a:cs typeface="Roboto"/>
-              </a:rPr>
-              <a:t>слышно?</a:t>
-            </a:r>
-            <a:endParaRPr sz="4000" dirty="0">
-              <a:latin typeface="Roboto"/>
-              <a:cs typeface="Roboto"/>
-            </a:endParaRPr>
-          </a:p>
-          <a:p>
-            <a:pPr marL="760095" marR="1526540">
-              <a:lnSpc>
-                <a:spcPct val="100000"/>
-              </a:lnSpc>
-              <a:spcBef>
-                <a:spcPts val="3900"/>
-              </a:spcBef>
-            </a:pPr>
-            <a:r>
-              <a:rPr sz="1500" spc="-10" dirty="0">
-                <a:latin typeface="Roboto"/>
-                <a:cs typeface="Roboto"/>
-              </a:rPr>
-              <a:t>Ставим </a:t>
-            </a:r>
-            <a:r>
-              <a:rPr sz="1500" spc="-25" dirty="0">
-                <a:latin typeface="Roboto"/>
-                <a:cs typeface="Roboto"/>
-              </a:rPr>
-              <a:t>“+”, </a:t>
-            </a:r>
-            <a:r>
-              <a:rPr sz="1500" spc="10" dirty="0">
-                <a:latin typeface="Roboto"/>
-                <a:cs typeface="Roboto"/>
-              </a:rPr>
-              <a:t>если </a:t>
-            </a:r>
-            <a:r>
-              <a:rPr sz="1500" dirty="0">
-                <a:latin typeface="Roboto"/>
-                <a:cs typeface="Roboto"/>
-              </a:rPr>
-              <a:t>все </a:t>
-            </a:r>
-            <a:r>
-              <a:rPr sz="1500" spc="-10" dirty="0">
-                <a:latin typeface="Roboto"/>
-                <a:cs typeface="Roboto"/>
-              </a:rPr>
-              <a:t>хорошо </a:t>
-            </a:r>
-            <a:r>
-              <a:rPr sz="1500" spc="-360" dirty="0">
-                <a:latin typeface="Roboto"/>
-                <a:cs typeface="Roboto"/>
-              </a:rPr>
-              <a:t> </a:t>
-            </a:r>
-            <a:r>
-              <a:rPr sz="1500" spc="-105" dirty="0">
-                <a:latin typeface="Roboto"/>
-                <a:cs typeface="Roboto"/>
-              </a:rPr>
-              <a:t>“-”</a:t>
-            </a:r>
-            <a:r>
-              <a:rPr sz="1500" spc="-50" dirty="0">
-                <a:latin typeface="Roboto"/>
-                <a:cs typeface="Roboto"/>
-              </a:rPr>
-              <a:t>,</a:t>
-            </a:r>
-            <a:r>
-              <a:rPr sz="1500" spc="-5" dirty="0">
-                <a:latin typeface="Roboto"/>
-                <a:cs typeface="Roboto"/>
-              </a:rPr>
-              <a:t> </a:t>
-            </a:r>
-            <a:r>
-              <a:rPr sz="1500" spc="5" dirty="0">
-                <a:latin typeface="Roboto"/>
-                <a:cs typeface="Roboto"/>
-              </a:rPr>
-              <a:t>есл</a:t>
-            </a:r>
-            <a:r>
-              <a:rPr sz="1500" spc="15" dirty="0">
-                <a:latin typeface="Roboto"/>
-                <a:cs typeface="Roboto"/>
-              </a:rPr>
-              <a:t>и</a:t>
-            </a:r>
-            <a:r>
-              <a:rPr sz="1500" spc="-5" dirty="0">
-                <a:latin typeface="Roboto"/>
-                <a:cs typeface="Roboto"/>
-              </a:rPr>
-              <a:t> </a:t>
-            </a:r>
-            <a:r>
-              <a:rPr sz="1500" spc="-15" dirty="0">
-                <a:latin typeface="Roboto"/>
-                <a:cs typeface="Roboto"/>
-              </a:rPr>
-              <a:t>ест</a:t>
-            </a:r>
-            <a:r>
-              <a:rPr sz="1500" spc="-10" dirty="0">
-                <a:latin typeface="Roboto"/>
-                <a:cs typeface="Roboto"/>
-              </a:rPr>
-              <a:t>ь</a:t>
-            </a:r>
-            <a:r>
-              <a:rPr sz="1500" spc="-5" dirty="0">
-                <a:latin typeface="Roboto"/>
-                <a:cs typeface="Roboto"/>
-              </a:rPr>
-              <a:t> проблемы</a:t>
-            </a:r>
-            <a:endParaRPr sz="1500" dirty="0">
-              <a:latin typeface="Roboto"/>
-              <a:cs typeface="Roboto"/>
-            </a:endParaRPr>
-          </a:p>
-        </p:txBody>
-      </p:sp>
-    </p:spTree>
   </p:cSld>
   <p:clrMapOvr>
     <a:masterClrMapping/>
@@ -11201,7 +13696,7 @@
         </p:nvSpPr>
         <p:spPr>
           <a:xfrm>
-            <a:off x="740238" y="1074905"/>
+            <a:off x="703140" y="1624647"/>
             <a:ext cx="4214193" cy="376200"/>
           </a:xfrm>
           <a:prstGeom prst="roundRect">
@@ -11295,7 +13790,7 @@
         </p:nvSpPr>
         <p:spPr>
           <a:xfrm>
-            <a:off x="738806" y="2832451"/>
+            <a:off x="703138" y="2290122"/>
             <a:ext cx="4214195" cy="376200"/>
           </a:xfrm>
           <a:prstGeom prst="roundRect">
@@ -11418,54 +13913,22 @@
       </p:sp>
       <p:cxnSp>
         <p:nvCxnSpPr>
-          <p:cNvPr id="240" name="Google Shape;240;p37"/>
+          <p:cNvPr id="242" name="Google Shape;242;p37"/>
           <p:cNvCxnSpPr>
             <a:cxnSpLocks/>
-            <a:stCxn id="235" idx="1"/>
-            <a:endCxn id="236" idx="1"/>
+            <a:stCxn id="238" idx="1"/>
+            <a:endCxn id="15" idx="1"/>
           </p:cNvCxnSpPr>
           <p:nvPr/>
         </p:nvCxnSpPr>
         <p:spPr>
-          <a:xfrm rot="10800000" flipV="1">
-            <a:off x="738806" y="1263005"/>
-            <a:ext cx="1432" cy="1757546"/>
+          <a:xfrm rot="10800000">
+            <a:off x="740239" y="4042573"/>
+            <a:ext cx="12700" cy="665475"/>
           </a:xfrm>
           <a:prstGeom prst="curvedConnector3">
             <a:avLst>
-              <a:gd name="adj1" fmla="val 16063687"/>
-            </a:avLst>
-          </a:prstGeom>
-          <a:noFill/>
-          <a:ln w="9525" cap="flat" cmpd="sng">
-            <a:solidFill>
-              <a:schemeClr val="dk1"/>
-            </a:solidFill>
-            <a:prstDash val="dash"/>
-            <a:round/>
-            <a:headEnd type="none" w="sm" len="sm"/>
-            <a:tailEnd type="none" w="sm" len="sm"/>
-          </a:ln>
-        </p:spPr>
-      </p:cxnSp>
-      <p:cxnSp>
-        <p:nvCxnSpPr>
-          <p:cNvPr id="242" name="Google Shape;242;p37"/>
-          <p:cNvCxnSpPr>
-            <a:cxnSpLocks/>
-            <a:stCxn id="236" idx="1"/>
-            <a:endCxn id="238" idx="1"/>
-          </p:cNvCxnSpPr>
-          <p:nvPr/>
-        </p:nvCxnSpPr>
-        <p:spPr>
-          <a:xfrm rot="10800000" flipH="1" flipV="1">
-            <a:off x="738805" y="3020551"/>
-            <a:ext cx="1433" cy="1687496"/>
-          </a:xfrm>
-          <a:prstGeom prst="curvedConnector3">
-            <a:avLst>
-              <a:gd name="adj1" fmla="val -15952547"/>
+              <a:gd name="adj1" fmla="val 1800000"/>
             </a:avLst>
           </a:prstGeom>
           <a:noFill/>
@@ -11509,7 +13972,7 @@
         </p:blipFill>
         <p:spPr bwMode="auto">
           <a:xfrm>
-            <a:off x="5510915" y="1074905"/>
+            <a:off x="5334000" y="1405953"/>
             <a:ext cx="3062624" cy="1723820"/>
           </a:xfrm>
           <a:prstGeom prst="rect">
@@ -11556,7 +14019,7 @@
         </p:blipFill>
         <p:spPr bwMode="auto">
           <a:xfrm>
-            <a:off x="5334000" y="3071792"/>
+            <a:off x="5207866" y="3176521"/>
             <a:ext cx="3630520" cy="1636255"/>
           </a:xfrm>
           <a:prstGeom prst="rect">
@@ -11574,6 +14037,296 @@
           </a:extLst>
         </p:spPr>
       </p:pic>
+      <p:sp>
+        <p:nvSpPr>
+          <p:cNvPr id="14" name="Google Shape;235;p37">
+            <a:extLst>
+              <a:ext uri="{FF2B5EF4-FFF2-40B4-BE49-F238E27FC236}">
+                <a16:creationId xmlns:a16="http://schemas.microsoft.com/office/drawing/2014/main" id="{5B7CDC4F-8813-674D-8E40-29B8F61514E0}"/>
+              </a:ext>
+            </a:extLst>
+          </p:cNvPr>
+          <p:cNvSpPr/>
+          <p:nvPr/>
+        </p:nvSpPr>
+        <p:spPr>
+          <a:xfrm>
+            <a:off x="708902" y="2955597"/>
+            <a:ext cx="4214193" cy="609600"/>
+          </a:xfrm>
+          <a:prstGeom prst="roundRect">
+            <a:avLst>
+              <a:gd name="adj" fmla="val 16667"/>
+            </a:avLst>
+          </a:prstGeom>
+          <a:solidFill>
+            <a:srgbClr val="FFD966"/>
+          </a:solidFill>
+          <a:ln>
+            <a:noFill/>
+          </a:ln>
+        </p:spPr>
+        <p:txBody>
+          <a:bodyPr spcFirstLastPara="1" wrap="square" lIns="162000" tIns="91425" rIns="162000" bIns="91425" anchor="ctr" anchorCtr="0">
+            <a:noAutofit/>
+          </a:bodyPr>
+          <a:lstStyle/>
+          <a:p>
+            <a:pPr marL="0" marR="0" lvl="0" indent="0" algn="l" rtl="0">
+              <a:lnSpc>
+                <a:spcPct val="100000"/>
+              </a:lnSpc>
+              <a:spcBef>
+                <a:spcPts val="0"/>
+              </a:spcBef>
+              <a:spcAft>
+                <a:spcPts val="0"/>
+              </a:spcAft>
+              <a:buClr>
+                <a:srgbClr val="000000"/>
+              </a:buClr>
+              <a:buSzPts val="1600"/>
+              <a:buFont typeface="Arial"/>
+              <a:buNone/>
+            </a:pPr>
+            <a:r>
+              <a:rPr lang="ru-RU" sz="1600" dirty="0">
+                <a:solidFill>
+                  <a:schemeClr val="dk1"/>
+                </a:solidFill>
+                <a:latin typeface="Roboto"/>
+                <a:ea typeface="Roboto"/>
+                <a:cs typeface="Roboto"/>
+                <a:sym typeface="Roboto"/>
+              </a:rPr>
+              <a:t>Стратификация</a:t>
+            </a:r>
+            <a:r>
+              <a:rPr lang="en-US" sz="1600" dirty="0">
+                <a:solidFill>
+                  <a:schemeClr val="dk1"/>
+                </a:solidFill>
+                <a:latin typeface="Roboto"/>
+                <a:ea typeface="Roboto"/>
+                <a:cs typeface="Roboto"/>
+                <a:sym typeface="Roboto"/>
+              </a:rPr>
+              <a:t> – </a:t>
+            </a:r>
+            <a:r>
+              <a:rPr lang="ru-RU" sz="1600" dirty="0">
+                <a:solidFill>
+                  <a:schemeClr val="dk1"/>
+                </a:solidFill>
+                <a:latin typeface="Roboto"/>
+                <a:ea typeface="Roboto"/>
+                <a:cs typeface="Roboto"/>
+                <a:sym typeface="Roboto"/>
+              </a:rPr>
+              <a:t>повышение чувствительности</a:t>
+            </a:r>
+            <a:endParaRPr lang="ru-RU" sz="1600" b="0" i="0" u="none" strike="noStrike" cap="none" dirty="0">
+              <a:solidFill>
+                <a:schemeClr val="dk1"/>
+              </a:solidFill>
+              <a:latin typeface="Roboto"/>
+              <a:ea typeface="Roboto"/>
+              <a:cs typeface="Roboto"/>
+              <a:sym typeface="Roboto"/>
+            </a:endParaRPr>
+          </a:p>
+        </p:txBody>
+      </p:sp>
+      <p:sp>
+        <p:nvSpPr>
+          <p:cNvPr id="15" name="Google Shape;235;p37">
+            <a:extLst>
+              <a:ext uri="{FF2B5EF4-FFF2-40B4-BE49-F238E27FC236}">
+                <a16:creationId xmlns:a16="http://schemas.microsoft.com/office/drawing/2014/main" id="{74334085-1156-D547-B5CE-40C6F022CDCC}"/>
+              </a:ext>
+            </a:extLst>
+          </p:cNvPr>
+          <p:cNvSpPr/>
+          <p:nvPr/>
+        </p:nvSpPr>
+        <p:spPr>
+          <a:xfrm>
+            <a:off x="740239" y="3854472"/>
+            <a:ext cx="4214193" cy="376200"/>
+          </a:xfrm>
+          <a:prstGeom prst="roundRect">
+            <a:avLst>
+              <a:gd name="adj" fmla="val 16667"/>
+            </a:avLst>
+          </a:prstGeom>
+          <a:solidFill>
+            <a:srgbClr val="FFD966"/>
+          </a:solidFill>
+          <a:ln>
+            <a:noFill/>
+          </a:ln>
+        </p:spPr>
+        <p:txBody>
+          <a:bodyPr spcFirstLastPara="1" wrap="square" lIns="162000" tIns="91425" rIns="162000" bIns="91425" anchor="ctr" anchorCtr="0">
+            <a:noAutofit/>
+          </a:bodyPr>
+          <a:lstStyle/>
+          <a:p>
+            <a:pPr marL="0" marR="0" lvl="0" indent="0" algn="l" rtl="0">
+              <a:lnSpc>
+                <a:spcPct val="100000"/>
+              </a:lnSpc>
+              <a:spcBef>
+                <a:spcPts val="0"/>
+              </a:spcBef>
+              <a:spcAft>
+                <a:spcPts val="0"/>
+              </a:spcAft>
+              <a:buClr>
+                <a:srgbClr val="000000"/>
+              </a:buClr>
+              <a:buSzPts val="1600"/>
+              <a:buFont typeface="Arial"/>
+              <a:buNone/>
+            </a:pPr>
+            <a:r>
+              <a:rPr lang="en-US" sz="1600" dirty="0">
+                <a:solidFill>
+                  <a:schemeClr val="dk1"/>
+                </a:solidFill>
+                <a:latin typeface="Roboto"/>
+                <a:ea typeface="Roboto"/>
+                <a:cs typeface="Roboto"/>
+                <a:sym typeface="Roboto"/>
+              </a:rPr>
+              <a:t>CUPED</a:t>
+            </a:r>
+            <a:endParaRPr lang="ru-RU" sz="1600" b="0" i="0" u="none" strike="noStrike" cap="none" dirty="0">
+              <a:solidFill>
+                <a:schemeClr val="dk1"/>
+              </a:solidFill>
+              <a:latin typeface="Roboto"/>
+              <a:ea typeface="Roboto"/>
+              <a:cs typeface="Roboto"/>
+              <a:sym typeface="Roboto"/>
+            </a:endParaRPr>
+          </a:p>
+        </p:txBody>
+      </p:sp>
+      <p:cxnSp>
+        <p:nvCxnSpPr>
+          <p:cNvPr id="19" name="Google Shape;242;p37">
+            <a:extLst>
+              <a:ext uri="{FF2B5EF4-FFF2-40B4-BE49-F238E27FC236}">
+                <a16:creationId xmlns:a16="http://schemas.microsoft.com/office/drawing/2014/main" id="{57B81F5F-1189-1D4E-8B84-635DB1BDADF8}"/>
+              </a:ext>
+            </a:extLst>
+          </p:cNvPr>
+          <p:cNvCxnSpPr>
+            <a:cxnSpLocks/>
+            <a:stCxn id="236" idx="1"/>
+            <a:endCxn id="235" idx="1"/>
+          </p:cNvCxnSpPr>
+          <p:nvPr/>
+        </p:nvCxnSpPr>
+        <p:spPr>
+          <a:xfrm rot="10800000" flipH="1">
+            <a:off x="703138" y="1812748"/>
+            <a:ext cx="2" cy="665475"/>
+          </a:xfrm>
+          <a:prstGeom prst="curvedConnector3">
+            <a:avLst>
+              <a:gd name="adj1" fmla="val -11430000000"/>
+            </a:avLst>
+          </a:prstGeom>
+          <a:noFill/>
+          <a:ln w="9525" cap="flat" cmpd="sng">
+            <a:solidFill>
+              <a:schemeClr val="dk1"/>
+            </a:solidFill>
+            <a:prstDash val="dash"/>
+            <a:round/>
+            <a:headEnd type="none" w="sm" len="sm"/>
+            <a:tailEnd type="none" w="sm" len="sm"/>
+          </a:ln>
+        </p:spPr>
+      </p:cxnSp>
+      <p:cxnSp>
+        <p:nvCxnSpPr>
+          <p:cNvPr id="22" name="Google Shape;242;p37">
+            <a:extLst>
+              <a:ext uri="{FF2B5EF4-FFF2-40B4-BE49-F238E27FC236}">
+                <a16:creationId xmlns:a16="http://schemas.microsoft.com/office/drawing/2014/main" id="{F7FBB00E-AA74-BC43-B475-9696CCECA13C}"/>
+              </a:ext>
+            </a:extLst>
+          </p:cNvPr>
+          <p:cNvCxnSpPr>
+            <a:cxnSpLocks/>
+            <a:stCxn id="14" idx="1"/>
+            <a:endCxn id="236" idx="1"/>
+          </p:cNvCxnSpPr>
+          <p:nvPr/>
+        </p:nvCxnSpPr>
+        <p:spPr>
+          <a:xfrm rot="10800000">
+            <a:off x="703138" y="2478223"/>
+            <a:ext cx="5764" cy="782175"/>
+          </a:xfrm>
+          <a:prstGeom prst="curvedConnector3">
+            <a:avLst>
+              <a:gd name="adj1" fmla="val 4065996"/>
+            </a:avLst>
+          </a:prstGeom>
+          <a:noFill/>
+          <a:ln w="9525" cap="flat" cmpd="sng">
+            <a:solidFill>
+              <a:schemeClr val="dk1"/>
+            </a:solidFill>
+            <a:prstDash val="dash"/>
+            <a:round/>
+            <a:headEnd type="none" w="sm" len="sm"/>
+            <a:tailEnd type="none" w="sm" len="sm"/>
+          </a:ln>
+        </p:spPr>
+      </p:cxnSp>
+      <p:cxnSp>
+        <p:nvCxnSpPr>
+          <p:cNvPr id="25" name="Google Shape;242;p37">
+            <a:extLst>
+              <a:ext uri="{FF2B5EF4-FFF2-40B4-BE49-F238E27FC236}">
+                <a16:creationId xmlns:a16="http://schemas.microsoft.com/office/drawing/2014/main" id="{28868F21-4379-3247-9F53-3EEC819B1642}"/>
+              </a:ext>
+            </a:extLst>
+          </p:cNvPr>
+          <p:cNvCxnSpPr>
+            <a:cxnSpLocks/>
+            <a:stCxn id="15" idx="1"/>
+            <a:endCxn id="14" idx="1"/>
+          </p:cNvCxnSpPr>
+          <p:nvPr/>
+        </p:nvCxnSpPr>
+        <p:spPr>
+          <a:xfrm rot="10800000">
+            <a:off x="708903" y="3260398"/>
+            <a:ext cx="31337" cy="782175"/>
+          </a:xfrm>
+          <a:prstGeom prst="curvedConnector3">
+            <a:avLst>
+              <a:gd name="adj1" fmla="val 829489"/>
+            </a:avLst>
+          </a:prstGeom>
+          <a:noFill/>
+          <a:ln w="9525" cap="flat" cmpd="sng">
+            <a:solidFill>
+              <a:schemeClr val="dk1"/>
+            </a:solidFill>
+            <a:prstDash val="dash"/>
+            <a:round/>
+            <a:headEnd type="none" w="sm" len="sm"/>
+            <a:tailEnd type="none" w="sm" len="sm"/>
+          </a:ln>
+        </p:spPr>
+      </p:cxnSp>
     </p:spTree>
   </p:cSld>
   <p:clrMapOvr>

</xml_diff>